<commit_message>
Welle 3: VA11 kuratiertes Deck + 2 Schaubilder (Web/Admin/Workbook)
Co-Authored-By: Claude Fable 5 <noreply@anthropic.com>
</commit_message>
<xml_diff>
--- a/protected-downloads/praesentation/VA11.pptx
+++ b/protected-downloads/praesentation/VA11.pptx
@@ -15,6 +15,12 @@
     <p:sldId id="263" r:id="rId15"/>
     <p:sldId id="264" r:id="rId16"/>
     <p:sldId id="265" r:id="rId17"/>
+    <p:sldId id="266" r:id="rId18"/>
+    <p:sldId id="267" r:id="rId19"/>
+    <p:sldId id="268" r:id="rId20"/>
+    <p:sldId id="269" r:id="rId21"/>
+    <p:sldId id="270" r:id="rId22"/>
+    <p:sldId id="271" r:id="rId23"/>
   </p:sldIdLst>
   <p:sldSz cx="12188952" cy="6858000" type="screen4x3"/>
   <p:notesSz cx="6858000" cy="9144000"/>
@@ -581,7 +587,7 @@
           <a:lstStyle/>
           <a:p>
             <a:r>
-              <a:t>Siehe Trainerhandbuch (Sektion 3) für Moderationshinweise, Timing und erwartete Teilnehmerreaktionen.</a:t>
+              <a:t>Organigramm am Flipchart schrittweise aufbauen. Aktivierende Frage: „Was passiert, wenn wir eine Beteiligungsgesellschaft vergessen?" Ketten-Beispiel an der Tafel vorrechnen.</a:t>
             </a:r>
           </a:p>
         </p:txBody>
@@ -651,7 +657,7 @@
           <a:lstStyle/>
           <a:p>
             <a:r>
-              <a:t>Siehe Trainerhandbuch (Sektion 3) für Moderationshinweise, Timing und erwartete Teilnehmerreaktionen.</a:t>
+              <a:t>Fehlerhaft gebildete Einheiten sind ein wiederkehrender Prüfungsbefund: zu eng = Großkreditgrenze unerkannt überschritten; zu weit = Kreditspielräume blockiert.</a:t>
             </a:r>
           </a:p>
         </p:txBody>
@@ -721,7 +727,7 @@
           <a:lstStyle/>
           <a:p>
             <a:r>
-              <a:t>Siehe Trainerhandbuch (Sektion 3) für Moderationshinweise, Timing und erwartete Teilnehmerreaktionen.</a:t>
+              <a:t>Die Meldung an die FIU (§ 43 GwG) macht der Geldwäschebeauftragte, nicht die Assistenz. Liegen Verdachtsmerkmale vor, ist die Meldung verpflichtend – unabhängig von Kundenwert oder Beraterwunsch (BaFin AuA).</a:t>
             </a:r>
           </a:p>
         </p:txBody>
@@ -791,7 +797,7 @@
           <a:lstStyle/>
           <a:p>
             <a:r>
-              <a:t>Siehe Trainerhandbuch (Sektion 3) für Moderationshinweise, Timing und erwartete Teilnehmerreaktionen.</a:t>
+              <a:t>Kernpunkt: die Muster Spedition GmbH steht unter zwei Einbeziehungsgründen. Rechenweg der wB-Kette gemeinsam vorführen. Taschenrechner bereitstellen.</a:t>
             </a:r>
           </a:p>
         </p:txBody>
@@ -861,67 +867,7 @@
           <a:lstStyle/>
           <a:p>
             <a:r>
-              <a:t>AB-1 Musterlösung (Trainer-Version)</a:t>
-            </a:r>
-          </a:p>
-          <a:p>
-            <a:r>
-              <a:t>Einheitenprüfung:</a:t>
-            </a:r>
-          </a:p>
-          <a:p>
-            <a:r>
-              <a:t>Georg Muster hält über die Muster Holding GmbH mittelbar 100 % an Muster Transport GmbH und Muster Logistik GmbH sowie mittelbar 40 % an Muster Spedition GmbH. Bei Muster Spedition GmbH hält Sandra Muster direkt 60 %. Da Georg Muster beherrschenden Einfluss auf die Holding ausübt und die Speditions-GmbH wirtschaftlich von der Logistik-GmbH abhängt (80 % Umsatzanteil), ist die gesamte Gruppe einzubeziehen. Sandra Muster hält direkt 60 % der Speditions-GmbH und übt damit selbst Beherrschung über diese Gesellschaft aus (§ 19 Abs. 2 KWG, Beherrschungstatbestand); als beherrschende natürliche Person ist sie deshalb – nicht „mit Vorbehalt", sondern regelhaft – in die Einheit einzubeziehen. Die Speditions-GmbH steht damit unter zwei Einbeziehungsgründen: Beherrschung durch Sandra Muster und wirtschaftliche Abhängigkeit von der Logistik-GmbH.</a:t>
-            </a:r>
-          </a:p>
-          <a:p>
-            <a:r>
-              <a:t>Gesamtengagement der Einheit: 750 + 400 + 200 = 1.350 TEUR</a:t>
-            </a:r>
-          </a:p>
-          <a:p>
-            <a:r>
-              <a:t>Kernbefund für Trainer: Der Fall zeigt zwei Einbeziehungsgründe nebeneinander: (1) Beherrschung – Sandra Muster ist mit 60 % beherrschende Gesellschafterin der Speditions-GmbH und damit klar einzubeziehen; (2) wirtschaftliche Abhängigkeit – die Speditions-GmbH hängt zu 80 % von der Logistik-GmbH ab, was sie zusätzlich an die Holding-Gruppe bindet. Lehrpointe: Einheitenbildung kann auch bei formaler Beteiligung &lt; 50 % greifen (über die wirtschaftliche Abhängigkeit). Die Assistenz erkennt und strukturiert beides; die verbindliche rechtliche Beurteilung schließt die Marktfolge ab.</a:t>
-            </a:r>
-          </a:p>
-          <a:p>
-            <a:r>
-              <a:t>Trainer-Hinweis: Die korrekte Einheitenbildung liegt letztlich bei der Marktfolge/Compliance. Die Assistenz soll erkennen, dass die Holding-Struktur und die wirtschaftliche Abhängigkeit der Speditions-GmbH kritisch sind – nicht selbst entscheiden. Den Teilnehmern klarmachen: Die Assistenz liefert die Struktur und markiert offene Fragen; die Marktfolge schließt die rechtliche Beurteilung ab. Zahlenbeispiel: Gesamtengagement 1.350 TEUR ist für viele VR-Banken Süddeutschlands bereits im Bereich der Großkreditprüfung relevant.</a:t>
-            </a:r>
-          </a:p>
-          <a:p>
-            <a:r>
-              <a:t>AB-2 Musterlösung (Trainer-Version)</a:t>
-            </a:r>
-          </a:p>
-          <a:p>
-            <a:r>
-              <a:t>Wirtschaftlich Berechtigter Muster Transport GmbH:</a:t>
-            </a:r>
-          </a:p>
-          <a:p>
-            <a:r>
-              <a:t>Direkt beteiligt: Muster Holding GmbH (100 %).</a:t>
-            </a:r>
-          </a:p>
-          <a:p>
-            <a:r>
-              <a:t>Durchgerechnet: Georg Muster hält 100 % der Holding → 100 % × 100 % = 100 % Beteiligung an Muster Transport GmbH.</a:t>
-            </a:r>
-          </a:p>
-          <a:p>
-            <a:r>
-              <a:t>Sandra Muster hat keine Beteiligung an der Transport GmbH (nur an der Speditions-GmbH direkt).</a:t>
-            </a:r>
-          </a:p>
-          <a:p>
-            <a:r>
-              <a:t>Wirtschaftlich Berechtigter: Georg Muster (&gt; 25 % direkt/mittelbar, kein Zweifel). Transparenzregister-Abgleich ist durchzuführen und zu dokumentieren.</a:t>
-            </a:r>
-          </a:p>
-          <a:p>
-            <a:r>
-              <a:t>Trainer-Hinweis: Betonen: In einer zweistufigen Kette (natürliche Person → Holding → GmbH) ist die Rechnung simpel, weil Georg Muster 100 % hält. In der Praxis sind Ketten komplexer (z. B. 70 % × 60 % = 42 % – immer noch &gt; 25 %). D</a:t>
+              <a:t>Die GwG-Sorgfaltspflicht steht über dem Berater-Wunsch und ist nicht ermessensabhängig. Die Verantwortung der Assistenz ist abgesichert, wenn sie dokumentiert und eskaliert.</a:t>
             </a:r>
           </a:p>
         </p:txBody>
@@ -991,7 +937,157 @@
           <a:lstStyle/>
           <a:p>
             <a:r>
-              <a:t>Siehe Trainerhandbuch (Sektion 3) für Moderationshinweise, Timing und erwartete Teilnehmerreaktionen.</a:t>
+              <a:t>AB-1/AB-2 Musterlösung (Trainer-Version)</a:t>
+            </a:r>
+          </a:p>
+          <a:p>
+            <a:r>
+              <a:t>Muster Spedition GmbH steht unter zwei Einbeziehungsgründen. wB-Kette über die Holding durchrechnen (über 25 % = wB).</a:t>
+            </a:r>
+          </a:p>
+          <a:p>
+            <a:r>
+              <a:t>Trainer-Hinweis: das Tipping-off-Verbot an Szenario A explizit herausarbeiten – der Kunde darf nicht gewarnt werden.</a:t>
+            </a:r>
+          </a:p>
+        </p:txBody>
+      </p:sp>
+      <p:sp>
+        <p:nvSpPr>
+          <p:cNvPr id="4" name="Slide Number Placeholder 3"/>
+          <p:cNvSpPr>
+            <a:spLocks noGrp="1"/>
+          </p:cNvSpPr>
+          <p:nvPr>
+            <p:ph type="sldNum" idx="5" sz="quarter"/>
+          </p:nvPr>
+        </p:nvSpPr>
+        <p:spPr/>
+      </p:sp>
+    </p:spTree>
+  </p:cSld>
+  <p:clrMapOvr>
+    <a:masterClrMapping/>
+  </p:clrMapOvr>
+</p:notes>
+</file>
+
+<file path=ppt/notesSlides/notesSlide8.xml><?xml version="1.0" encoding="utf-8"?>
+<p:notes xmlns:a="http://schemas.openxmlformats.org/drawingml/2006/main" xmlns:p="http://schemas.openxmlformats.org/presentationml/2006/main" xmlns:r="http://schemas.openxmlformats.org/officeDocument/2006/relationships">
+  <p:cSld>
+    <p:spTree>
+      <p:nvGrpSpPr>
+        <p:cNvPr id="1" name=""/>
+        <p:cNvGrpSpPr/>
+        <p:nvPr/>
+      </p:nvGrpSpPr>
+      <p:grpSpPr>
+        <a:xfrm>
+          <a:off x="0" y="0"/>
+          <a:ext cx="0" cy="0"/>
+          <a:chOff x="0" y="0"/>
+          <a:chExt cx="0" cy="0"/>
+        </a:xfrm>
+      </p:grpSpPr>
+      <p:sp>
+        <p:nvSpPr>
+          <p:cNvPr id="2" name="Slide Image Placeholder 1"/>
+          <p:cNvSpPr>
+            <a:spLocks noGrp="1"/>
+          </p:cNvSpPr>
+          <p:nvPr>
+            <p:ph type="sldImg" idx="2"/>
+          </p:nvPr>
+        </p:nvSpPr>
+        <p:spPr/>
+      </p:sp>
+      <p:sp>
+        <p:nvSpPr>
+          <p:cNvPr id="3" name="Notes Placeholder 2"/>
+          <p:cNvSpPr>
+            <a:spLocks noGrp="1"/>
+          </p:cNvSpPr>
+          <p:nvPr>
+            <p:ph type="body" idx="3" sz="quarter"/>
+          </p:nvPr>
+        </p:nvSpPr>
+        <p:spPr/>
+        <p:txBody>
+          <a:bodyPr/>
+          <a:lstStyle/>
+          <a:p>
+            <a:r>
+              <a:t>Drei Kernbotschaften: Einheit bilden, wB ermitteln, Verdacht melden. VA11 schließt das Kompetenzfeld K-A06 ab.</a:t>
+            </a:r>
+          </a:p>
+        </p:txBody>
+      </p:sp>
+      <p:sp>
+        <p:nvSpPr>
+          <p:cNvPr id="4" name="Slide Number Placeholder 3"/>
+          <p:cNvSpPr>
+            <a:spLocks noGrp="1"/>
+          </p:cNvSpPr>
+          <p:nvPr>
+            <p:ph type="sldNum" idx="5" sz="quarter"/>
+          </p:nvPr>
+        </p:nvSpPr>
+        <p:spPr/>
+      </p:sp>
+    </p:spTree>
+  </p:cSld>
+  <p:clrMapOvr>
+    <a:masterClrMapping/>
+  </p:clrMapOvr>
+</p:notes>
+</file>
+
+<file path=ppt/notesSlides/notesSlide9.xml><?xml version="1.0" encoding="utf-8"?>
+<p:notes xmlns:a="http://schemas.openxmlformats.org/drawingml/2006/main" xmlns:p="http://schemas.openxmlformats.org/presentationml/2006/main" xmlns:r="http://schemas.openxmlformats.org/officeDocument/2006/relationships">
+  <p:cSld>
+    <p:spTree>
+      <p:nvGrpSpPr>
+        <p:cNvPr id="1" name=""/>
+        <p:cNvGrpSpPr/>
+        <p:nvPr/>
+      </p:nvGrpSpPr>
+      <p:grpSpPr>
+        <a:xfrm>
+          <a:off x="0" y="0"/>
+          <a:ext cx="0" cy="0"/>
+          <a:chOff x="0" y="0"/>
+          <a:chExt cx="0" cy="0"/>
+        </a:xfrm>
+      </p:grpSpPr>
+      <p:sp>
+        <p:nvSpPr>
+          <p:cNvPr id="2" name="Slide Image Placeholder 1"/>
+          <p:cNvSpPr>
+            <a:spLocks noGrp="1"/>
+          </p:cNvSpPr>
+          <p:nvPr>
+            <p:ph type="sldImg" idx="2"/>
+          </p:nvPr>
+        </p:nvSpPr>
+        <p:spPr/>
+      </p:sp>
+      <p:sp>
+        <p:nvSpPr>
+          <p:cNvPr id="3" name="Notes Placeholder 2"/>
+          <p:cNvSpPr>
+            <a:spLocks noGrp="1"/>
+          </p:cNvSpPr>
+          <p:nvPr>
+            <p:ph type="body" idx="3" sz="quarter"/>
+          </p:nvPr>
+        </p:nvSpPr>
+        <p:spPr/>
+        <p:txBody>
+          <a:bodyPr/>
+          <a:lstStyle/>
+          <a:p>
+            <a:r>
+              <a:t>Reflexionsfrage 3 im Plenum. Prüfkarte AB-5 übergeben, Evaluation austeilen.</a:t>
             </a:r>
           </a:p>
         </p:txBody>
@@ -4587,7 +4683,7 @@
             <a:avLst/>
           </a:prstGeom>
           <a:solidFill>
-            <a:srgbClr val="EDEDF3"/>
+            <a:srgbClr val="FFFFFF"/>
           </a:solidFill>
           <a:ln>
             <a:noFill/>
@@ -4688,6 +4784,604 @@
                 </a:solidFill>
                 <a:latin typeface="Consolas"/>
               </a:rPr>
+              <a:t>VA11  ·  SCHAUBILD</a:t>
+            </a:r>
+          </a:p>
+        </p:txBody>
+      </p:sp>
+      <p:sp>
+        <p:nvSpPr>
+          <p:cNvPr id="5" name="TextBox 4"/>
+          <p:cNvSpPr txBox="1"/>
+          <p:nvPr/>
+        </p:nvSpPr>
+        <p:spPr>
+          <a:xfrm>
+            <a:off x="685800" y="502920"/>
+            <a:ext cx="10817352" cy="594360"/>
+          </a:xfrm>
+          <a:prstGeom prst="rect">
+            <a:avLst/>
+          </a:prstGeom>
+          <a:noFill/>
+        </p:spPr>
+        <p:txBody>
+          <a:bodyPr wrap="square">
+            <a:spAutoFit/>
+          </a:bodyPr>
+          <a:lstStyle/>
+          <a:p>
+            <a:pPr algn="l"/>
+            <a:r>
+              <a:rPr sz="2000" b="1" i="0">
+                <a:solidFill>
+                  <a:srgbClr val="1F2C56"/>
+                </a:solidFill>
+                <a:latin typeface="Arial"/>
+              </a:rPr>
+              <a:t>Verdacht erkennen und richtig eskalieren</a:t>
+            </a:r>
+          </a:p>
+        </p:txBody>
+      </p:sp>
+      <p:sp>
+        <p:nvSpPr>
+          <p:cNvPr id="6" name="Rectangle 5"/>
+          <p:cNvSpPr/>
+          <p:nvPr/>
+        </p:nvSpPr>
+        <p:spPr>
+          <a:xfrm>
+            <a:off x="685800" y="1143000"/>
+            <a:ext cx="10817352" cy="25400"/>
+          </a:xfrm>
+          <a:prstGeom prst="rect">
+            <a:avLst/>
+          </a:prstGeom>
+          <a:solidFill>
+            <a:srgbClr val="D9C089"/>
+          </a:solidFill>
+          <a:ln>
+            <a:noFill/>
+          </a:ln>
+        </p:spPr>
+        <p:style>
+          <a:lnRef idx="1">
+            <a:schemeClr val="accent1"/>
+          </a:lnRef>
+          <a:fillRef idx="3">
+            <a:schemeClr val="accent1"/>
+          </a:fillRef>
+          <a:effectRef idx="2">
+            <a:schemeClr val="accent1"/>
+          </a:effectRef>
+          <a:fontRef idx="minor">
+            <a:schemeClr val="lt1"/>
+          </a:fontRef>
+        </p:style>
+        <p:txBody>
+          <a:bodyPr rtlCol="0" anchor="ctr"/>
+          <a:lstStyle/>
+          <a:p>
+            <a:pPr algn="ctr"/>
+          </a:p>
+        </p:txBody>
+      </p:sp>
+      <p:pic>
+        <p:nvPicPr>
+          <p:cNvPr id="7" name="Picture 6" descr="image.png"/>
+          <p:cNvPicPr>
+            <a:picLocks noChangeAspect="1"/>
+          </p:cNvPicPr>
+          <p:nvPr/>
+        </p:nvPicPr>
+        <p:blipFill>
+          <a:blip r:embed="rId2"/>
+          <a:stretch>
+            <a:fillRect/>
+          </a:stretch>
+        </p:blipFill>
+        <p:spPr>
+          <a:xfrm>
+            <a:off x="2303489" y="1325880"/>
+            <a:ext cx="7581973" cy="4937760"/>
+          </a:xfrm>
+          <a:prstGeom prst="rect">
+            <a:avLst/>
+          </a:prstGeom>
+        </p:spPr>
+      </p:pic>
+      <p:sp>
+        <p:nvSpPr>
+          <p:cNvPr id="8" name="Rectangle 7"/>
+          <p:cNvSpPr/>
+          <p:nvPr/>
+        </p:nvSpPr>
+        <p:spPr>
+          <a:xfrm>
+            <a:off x="0" y="6510528"/>
+            <a:ext cx="12188952" cy="347472"/>
+          </a:xfrm>
+          <a:prstGeom prst="rect">
+            <a:avLst/>
+          </a:prstGeom>
+          <a:solidFill>
+            <a:srgbClr val="0A1937"/>
+          </a:solidFill>
+          <a:ln>
+            <a:noFill/>
+          </a:ln>
+        </p:spPr>
+        <p:style>
+          <a:lnRef idx="1">
+            <a:schemeClr val="accent1"/>
+          </a:lnRef>
+          <a:fillRef idx="3">
+            <a:schemeClr val="accent1"/>
+          </a:fillRef>
+          <a:effectRef idx="2">
+            <a:schemeClr val="accent1"/>
+          </a:effectRef>
+          <a:fontRef idx="minor">
+            <a:schemeClr val="lt1"/>
+          </a:fontRef>
+        </p:style>
+        <p:txBody>
+          <a:bodyPr rtlCol="0" anchor="ctr"/>
+          <a:lstStyle/>
+          <a:p>
+            <a:pPr algn="ctr"/>
+          </a:p>
+        </p:txBody>
+      </p:sp>
+      <p:sp>
+        <p:nvSpPr>
+          <p:cNvPr id="9" name="TextBox 8"/>
+          <p:cNvSpPr txBox="1"/>
+          <p:nvPr/>
+        </p:nvSpPr>
+        <p:spPr>
+          <a:xfrm>
+            <a:off x="685800" y="6583680"/>
+            <a:ext cx="6490411" cy="256032"/>
+          </a:xfrm>
+          <a:prstGeom prst="rect">
+            <a:avLst/>
+          </a:prstGeom>
+          <a:noFill/>
+        </p:spPr>
+        <p:txBody>
+          <a:bodyPr wrap="none">
+            <a:spAutoFit/>
+          </a:bodyPr>
+          <a:lstStyle/>
+          <a:p>
+            <a:pPr algn="l"/>
+            <a:r>
+              <a:rPr sz="700">
+                <a:solidFill>
+                  <a:srgbClr val="A0B4D2"/>
+                </a:solidFill>
+                <a:latin typeface="Consolas"/>
+              </a:rPr>
+              <a:t>FKB Campus  ·  VA11</a:t>
+            </a:r>
+          </a:p>
+        </p:txBody>
+      </p:sp>
+      <p:sp>
+        <p:nvSpPr>
+          <p:cNvPr id="10" name="TextBox 9"/>
+          <p:cNvSpPr txBox="1"/>
+          <p:nvPr/>
+        </p:nvSpPr>
+        <p:spPr>
+          <a:xfrm>
+            <a:off x="7176211" y="6583680"/>
+            <a:ext cx="4326940" cy="256032"/>
+          </a:xfrm>
+          <a:prstGeom prst="rect">
+            <a:avLst/>
+          </a:prstGeom>
+          <a:noFill/>
+        </p:spPr>
+        <p:txBody>
+          <a:bodyPr wrap="none">
+            <a:spAutoFit/>
+          </a:bodyPr>
+          <a:lstStyle/>
+          <a:p>
+            <a:pPr algn="r"/>
+            <a:r>
+              <a:rPr sz="700">
+                <a:solidFill>
+                  <a:srgbClr val="A0B4D2"/>
+                </a:solidFill>
+                <a:latin typeface="Consolas"/>
+              </a:rPr>
+              <a:t>Schaubild</a:t>
+            </a:r>
+          </a:p>
+        </p:txBody>
+      </p:sp>
+    </p:spTree>
+  </p:cSld>
+  <p:clrMapOvr>
+    <a:masterClrMapping/>
+  </p:clrMapOvr>
+</p:sld>
+</file>
+
+<file path=ppt/slides/slide11.xml><?xml version="1.0" encoding="utf-8"?>
+<p:sld xmlns:a="http://schemas.openxmlformats.org/drawingml/2006/main" xmlns:p="http://schemas.openxmlformats.org/presentationml/2006/main" xmlns:r="http://schemas.openxmlformats.org/officeDocument/2006/relationships">
+  <p:cSld>
+    <p:spTree>
+      <p:nvGrpSpPr>
+        <p:cNvPr id="1" name=""/>
+        <p:cNvGrpSpPr/>
+        <p:nvPr/>
+      </p:nvGrpSpPr>
+      <p:grpSpPr/>
+      <p:sp>
+        <p:nvSpPr>
+          <p:cNvPr id="2" name="Rectangle 1"/>
+          <p:cNvSpPr/>
+          <p:nvPr/>
+        </p:nvSpPr>
+        <p:spPr>
+          <a:xfrm>
+            <a:off x="0" y="0"/>
+            <a:ext cx="12188952" cy="6858000"/>
+          </a:xfrm>
+          <a:prstGeom prst="rect">
+            <a:avLst/>
+          </a:prstGeom>
+          <a:solidFill>
+            <a:srgbClr val="1F2C56"/>
+          </a:solidFill>
+          <a:ln>
+            <a:noFill/>
+          </a:ln>
+        </p:spPr>
+        <p:style>
+          <a:lnRef idx="1">
+            <a:schemeClr val="accent1"/>
+          </a:lnRef>
+          <a:fillRef idx="3">
+            <a:schemeClr val="accent1"/>
+          </a:fillRef>
+          <a:effectRef idx="2">
+            <a:schemeClr val="accent1"/>
+          </a:effectRef>
+          <a:fontRef idx="minor">
+            <a:schemeClr val="lt1"/>
+          </a:fontRef>
+        </p:style>
+        <p:txBody>
+          <a:bodyPr rtlCol="0" anchor="ctr"/>
+          <a:lstStyle/>
+          <a:p>
+            <a:pPr algn="ctr"/>
+          </a:p>
+        </p:txBody>
+      </p:sp>
+      <p:sp>
+        <p:nvSpPr>
+          <p:cNvPr id="3" name="TextBox 2"/>
+          <p:cNvSpPr txBox="1"/>
+          <p:nvPr/>
+        </p:nvSpPr>
+        <p:spPr>
+          <a:xfrm>
+            <a:off x="685800" y="2377440"/>
+            <a:ext cx="10817352" cy="365760"/>
+          </a:xfrm>
+          <a:prstGeom prst="rect">
+            <a:avLst/>
+          </a:prstGeom>
+          <a:noFill/>
+        </p:spPr>
+        <p:txBody>
+          <a:bodyPr wrap="none">
+            <a:spAutoFit/>
+          </a:bodyPr>
+          <a:lstStyle/>
+          <a:p>
+            <a:pPr algn="l"/>
+            <a:r>
+              <a:rPr sz="1200">
+                <a:solidFill>
+                  <a:srgbClr val="D9C089"/>
+                </a:solidFill>
+                <a:latin typeface="Consolas"/>
+              </a:rPr>
+              <a:t>00:40–01:20</a:t>
+            </a:r>
+          </a:p>
+        </p:txBody>
+      </p:sp>
+      <p:sp>
+        <p:nvSpPr>
+          <p:cNvPr id="4" name="Rectangle 3"/>
+          <p:cNvSpPr/>
+          <p:nvPr/>
+        </p:nvSpPr>
+        <p:spPr>
+          <a:xfrm>
+            <a:off x="685800" y="2788920"/>
+            <a:ext cx="548640" cy="38100"/>
+          </a:xfrm>
+          <a:prstGeom prst="rect">
+            <a:avLst/>
+          </a:prstGeom>
+          <a:solidFill>
+            <a:srgbClr val="D9C089"/>
+          </a:solidFill>
+          <a:ln>
+            <a:noFill/>
+          </a:ln>
+        </p:spPr>
+        <p:style>
+          <a:lnRef idx="1">
+            <a:schemeClr val="accent1"/>
+          </a:lnRef>
+          <a:fillRef idx="3">
+            <a:schemeClr val="accent1"/>
+          </a:fillRef>
+          <a:effectRef idx="2">
+            <a:schemeClr val="accent1"/>
+          </a:effectRef>
+          <a:fontRef idx="minor">
+            <a:schemeClr val="lt1"/>
+          </a:fontRef>
+        </p:style>
+        <p:txBody>
+          <a:bodyPr rtlCol="0" anchor="ctr"/>
+          <a:lstStyle/>
+          <a:p>
+            <a:pPr algn="ctr"/>
+          </a:p>
+        </p:txBody>
+      </p:sp>
+      <p:sp>
+        <p:nvSpPr>
+          <p:cNvPr id="5" name="TextBox 4"/>
+          <p:cNvSpPr txBox="1"/>
+          <p:nvPr/>
+        </p:nvSpPr>
+        <p:spPr>
+          <a:xfrm>
+            <a:off x="685800" y="3017520"/>
+            <a:ext cx="10817352" cy="1463040"/>
+          </a:xfrm>
+          <a:prstGeom prst="rect">
+            <a:avLst/>
+          </a:prstGeom>
+          <a:noFill/>
+        </p:spPr>
+        <p:txBody>
+          <a:bodyPr wrap="square">
+            <a:spAutoFit/>
+          </a:bodyPr>
+          <a:lstStyle/>
+          <a:p>
+            <a:pPr algn="l"/>
+            <a:r>
+              <a:rPr sz="4000" b="1" i="0">
+                <a:solidFill>
+                  <a:srgbClr val="FFFFFF"/>
+                </a:solidFill>
+                <a:latin typeface="Arial"/>
+              </a:rPr>
+              <a:t>Fallübergabe &amp; Fallarbeit</a:t>
+            </a:r>
+          </a:p>
+        </p:txBody>
+      </p:sp>
+      <p:sp>
+        <p:nvSpPr>
+          <p:cNvPr id="6" name="TextBox 5"/>
+          <p:cNvSpPr txBox="1"/>
+          <p:nvPr/>
+        </p:nvSpPr>
+        <p:spPr>
+          <a:xfrm>
+            <a:off x="685800" y="4480560"/>
+            <a:ext cx="8653881" cy="1280160"/>
+          </a:xfrm>
+          <a:prstGeom prst="rect">
+            <a:avLst/>
+          </a:prstGeom>
+          <a:noFill/>
+        </p:spPr>
+        <p:txBody>
+          <a:bodyPr wrap="square">
+            <a:spAutoFit/>
+          </a:bodyPr>
+          <a:lstStyle/>
+          <a:p>
+            <a:pPr algn="l"/>
+            <a:r>
+              <a:rPr sz="1600" b="0" i="0">
+                <a:solidFill>
+                  <a:srgbClr val="C8D2E6"/>
+                </a:solidFill>
+                <a:latin typeface="Arial"/>
+              </a:rPr>
+              <a:t>Muster Holding GmbH – Einheit bilden, wB ermitteln, Verdacht prüfen.</a:t>
+            </a:r>
+          </a:p>
+        </p:txBody>
+      </p:sp>
+      <p:sp>
+        <p:nvSpPr>
+          <p:cNvPr id="7" name="TextBox 6"/>
+          <p:cNvSpPr txBox="1"/>
+          <p:nvPr/>
+        </p:nvSpPr>
+        <p:spPr>
+          <a:xfrm>
+            <a:off x="685800" y="6355080"/>
+            <a:ext cx="10817352" cy="274320"/>
+          </a:xfrm>
+          <a:prstGeom prst="rect">
+            <a:avLst/>
+          </a:prstGeom>
+          <a:noFill/>
+        </p:spPr>
+        <p:txBody>
+          <a:bodyPr wrap="none">
+            <a:spAutoFit/>
+          </a:bodyPr>
+          <a:lstStyle/>
+          <a:p>
+            <a:pPr algn="l"/>
+            <a:r>
+              <a:rPr sz="700">
+                <a:solidFill>
+                  <a:srgbClr val="8CA0C3"/>
+                </a:solidFill>
+                <a:latin typeface="Consolas"/>
+              </a:rPr>
+              <a:t>FKB Campus  ·  VA11</a:t>
+            </a:r>
+          </a:p>
+        </p:txBody>
+      </p:sp>
+    </p:spTree>
+  </p:cSld>
+  <p:clrMapOvr>
+    <a:masterClrMapping/>
+  </p:clrMapOvr>
+</p:sld>
+</file>
+
+<file path=ppt/slides/slide12.xml><?xml version="1.0" encoding="utf-8"?>
+<p:sld xmlns:a="http://schemas.openxmlformats.org/drawingml/2006/main" xmlns:p="http://schemas.openxmlformats.org/presentationml/2006/main" xmlns:r="http://schemas.openxmlformats.org/officeDocument/2006/relationships">
+  <p:cSld>
+    <p:spTree>
+      <p:nvGrpSpPr>
+        <p:cNvPr id="1" name=""/>
+        <p:cNvGrpSpPr/>
+        <p:nvPr/>
+      </p:nvGrpSpPr>
+      <p:grpSpPr/>
+      <p:sp>
+        <p:nvSpPr>
+          <p:cNvPr id="2" name="Rectangle 1"/>
+          <p:cNvSpPr/>
+          <p:nvPr/>
+        </p:nvSpPr>
+        <p:spPr>
+          <a:xfrm>
+            <a:off x="0" y="0"/>
+            <a:ext cx="12188952" cy="6858000"/>
+          </a:xfrm>
+          <a:prstGeom prst="rect">
+            <a:avLst/>
+          </a:prstGeom>
+          <a:solidFill>
+            <a:srgbClr val="EDEDF3"/>
+          </a:solidFill>
+          <a:ln>
+            <a:noFill/>
+          </a:ln>
+        </p:spPr>
+        <p:style>
+          <a:lnRef idx="1">
+            <a:schemeClr val="accent1"/>
+          </a:lnRef>
+          <a:fillRef idx="3">
+            <a:schemeClr val="accent1"/>
+          </a:fillRef>
+          <a:effectRef idx="2">
+            <a:schemeClr val="accent1"/>
+          </a:effectRef>
+          <a:fontRef idx="minor">
+            <a:schemeClr val="lt1"/>
+          </a:fontRef>
+        </p:style>
+        <p:txBody>
+          <a:bodyPr rtlCol="0" anchor="ctr"/>
+          <a:lstStyle/>
+          <a:p>
+            <a:pPr algn="ctr"/>
+          </a:p>
+        </p:txBody>
+      </p:sp>
+      <p:sp>
+        <p:nvSpPr>
+          <p:cNvPr id="3" name="Rectangle 2"/>
+          <p:cNvSpPr/>
+          <p:nvPr/>
+        </p:nvSpPr>
+        <p:spPr>
+          <a:xfrm>
+            <a:off x="0" y="0"/>
+            <a:ext cx="12188952" cy="50292"/>
+          </a:xfrm>
+          <a:prstGeom prst="rect">
+            <a:avLst/>
+          </a:prstGeom>
+          <a:solidFill>
+            <a:srgbClr val="1F2C56"/>
+          </a:solidFill>
+          <a:ln>
+            <a:noFill/>
+          </a:ln>
+        </p:spPr>
+        <p:style>
+          <a:lnRef idx="1">
+            <a:schemeClr val="accent1"/>
+          </a:lnRef>
+          <a:fillRef idx="3">
+            <a:schemeClr val="accent1"/>
+          </a:fillRef>
+          <a:effectRef idx="2">
+            <a:schemeClr val="accent1"/>
+          </a:effectRef>
+          <a:fontRef idx="minor">
+            <a:schemeClr val="lt1"/>
+          </a:fontRef>
+        </p:style>
+        <p:txBody>
+          <a:bodyPr rtlCol="0" anchor="ctr"/>
+          <a:lstStyle/>
+          <a:p>
+            <a:pPr algn="ctr"/>
+          </a:p>
+        </p:txBody>
+      </p:sp>
+      <p:sp>
+        <p:nvSpPr>
+          <p:cNvPr id="4" name="TextBox 3"/>
+          <p:cNvSpPr txBox="1"/>
+          <p:nvPr/>
+        </p:nvSpPr>
+        <p:spPr>
+          <a:xfrm>
+            <a:off x="685800" y="109728"/>
+            <a:ext cx="10817352" cy="228600"/>
+          </a:xfrm>
+          <a:prstGeom prst="rect">
+            <a:avLst/>
+          </a:prstGeom>
+          <a:noFill/>
+        </p:spPr>
+        <p:txBody>
+          <a:bodyPr wrap="none">
+            <a:spAutoFit/>
+          </a:bodyPr>
+          <a:lstStyle/>
+          <a:p>
+            <a:pPr algn="l"/>
+            <a:r>
+              <a:rPr sz="750">
+                <a:solidFill>
+                  <a:srgbClr val="78808C"/>
+                </a:solidFill>
+                <a:latin typeface="Consolas"/>
+              </a:rPr>
               <a:t>VA11  ·  INHALT</a:t>
             </a:r>
           </a:p>
@@ -4809,7 +5503,7 @@
                 </a:solidFill>
                 <a:latin typeface="Arial"/>
               </a:rPr>
-              <a:t>Reflexionsfragen</a:t>
+              <a:t>Praxisfall: Beteiligungsstruktur Muster Holding</a:t>
             </a:r>
           </a:p>
         </p:txBody>
@@ -4835,6 +5529,25 @@
             <a:spAutoFit/>
           </a:bodyPr>
           <a:lstStyle/>
+          <a:p>
+            <a:pPr>
+              <a:spcBef>
+                <a:spcPts val="1000"/>
+              </a:spcBef>
+              <a:spcAft>
+                <a:spcPts val="200"/>
+              </a:spcAft>
+            </a:pPr>
+            <a:r>
+              <a:rPr sz="800" b="1">
+                <a:solidFill>
+                  <a:srgbClr val="78808C"/>
+                </a:solidFill>
+                <a:latin typeface="Consolas"/>
+              </a:rPr>
+              <a:t>DER FALL</a:t>
+            </a:r>
+          </a:p>
           <a:p>
             <a:pPr marL="190500" indent="-190500">
               <a:spcBef>
@@ -4851,7 +5564,7 @@
                 </a:solidFill>
                 <a:latin typeface="Arial"/>
               </a:rPr>
-              <a:t>▸  Welchen Bestandskunden würden Sie sich heute anschauen, um zu prüfen, ob möglicherweise eine Kreditnehmereinheit vorliegt, die bisher nicht als solche erfasst ist?</a:t>
+              <a:t>▸  Fünf Gesellschaften und zwei natürliche Personen bilden eine mehrstufige Beteiligungsstruktur.</a:t>
             </a:r>
           </a:p>
           <a:p>
@@ -4870,7 +5583,26 @@
                 </a:solidFill>
                 <a:latin typeface="Arial"/>
               </a:rPr>
-              <a:t>▸  Wie gehen Sie vor, wenn ein Geschäftsführer Ihnen sagt, er sei selbst der Eigentümer – und keine weiteren Beteiligungen vorhanden seien – Sie aber an anderer Stelle anders lautende Informationen haben?</a:t>
+              <a:t>▸  Sie erhalten das Organigramm mit den Beteiligungsquoten – und zwei Verdachtsszenarien.</a:t>
+            </a:r>
+          </a:p>
+          <a:p>
+            <a:pPr>
+              <a:spcBef>
+                <a:spcPts val="1000"/>
+              </a:spcBef>
+              <a:spcAft>
+                <a:spcPts val="200"/>
+              </a:spcAft>
+            </a:pPr>
+            <a:r>
+              <a:rPr sz="800" b="1">
+                <a:solidFill>
+                  <a:srgbClr val="78808C"/>
+                </a:solidFill>
+                <a:latin typeface="Consolas"/>
+              </a:rPr>
+              <a:t>IHRE AUFGABE</a:t>
             </a:r>
           </a:p>
           <a:p>
@@ -4889,7 +5621,1757 @@
                 </a:solidFill>
                 <a:latin typeface="Arial"/>
               </a:rPr>
-              <a:t>▸  Was würden Sie tun, wenn ein Berater Sie bittet, bei einem verdächtigen Vorgang erst einmal „nichts zu unternehmen, der Kunde ist wichtig"?</a:t>
+              <a:t>▸  Bilden Sie die Kreditnehmereinheit, ermitteln Sie den wirtschaftlich Berechtigten und bewerten Sie die Verdachtsszenarien.</a:t>
+            </a:r>
+          </a:p>
+        </p:txBody>
+      </p:sp>
+      <p:sp>
+        <p:nvSpPr>
+          <p:cNvPr id="9" name="Rectangle 8"/>
+          <p:cNvSpPr/>
+          <p:nvPr/>
+        </p:nvSpPr>
+        <p:spPr>
+          <a:xfrm>
+            <a:off x="0" y="6510528"/>
+            <a:ext cx="12188952" cy="347472"/>
+          </a:xfrm>
+          <a:prstGeom prst="rect">
+            <a:avLst/>
+          </a:prstGeom>
+          <a:solidFill>
+            <a:srgbClr val="0A1937"/>
+          </a:solidFill>
+          <a:ln>
+            <a:noFill/>
+          </a:ln>
+        </p:spPr>
+        <p:style>
+          <a:lnRef idx="1">
+            <a:schemeClr val="accent1"/>
+          </a:lnRef>
+          <a:fillRef idx="3">
+            <a:schemeClr val="accent1"/>
+          </a:fillRef>
+          <a:effectRef idx="2">
+            <a:schemeClr val="accent1"/>
+          </a:effectRef>
+          <a:fontRef idx="minor">
+            <a:schemeClr val="lt1"/>
+          </a:fontRef>
+        </p:style>
+        <p:txBody>
+          <a:bodyPr rtlCol="0" anchor="ctr"/>
+          <a:lstStyle/>
+          <a:p>
+            <a:pPr algn="ctr"/>
+          </a:p>
+        </p:txBody>
+      </p:sp>
+      <p:sp>
+        <p:nvSpPr>
+          <p:cNvPr id="10" name="TextBox 9"/>
+          <p:cNvSpPr txBox="1"/>
+          <p:nvPr/>
+        </p:nvSpPr>
+        <p:spPr>
+          <a:xfrm>
+            <a:off x="685800" y="6583680"/>
+            <a:ext cx="6490411" cy="256032"/>
+          </a:xfrm>
+          <a:prstGeom prst="rect">
+            <a:avLst/>
+          </a:prstGeom>
+          <a:noFill/>
+        </p:spPr>
+        <p:txBody>
+          <a:bodyPr wrap="none">
+            <a:spAutoFit/>
+          </a:bodyPr>
+          <a:lstStyle/>
+          <a:p>
+            <a:pPr algn="l"/>
+            <a:r>
+              <a:rPr sz="700">
+                <a:solidFill>
+                  <a:srgbClr val="A0B4D2"/>
+                </a:solidFill>
+                <a:latin typeface="Consolas"/>
+              </a:rPr>
+              <a:t>FKB Campus  ·  VA11</a:t>
+            </a:r>
+          </a:p>
+        </p:txBody>
+      </p:sp>
+    </p:spTree>
+  </p:cSld>
+  <p:clrMapOvr>
+    <a:masterClrMapping/>
+  </p:clrMapOvr>
+</p:sld>
+</file>
+
+<file path=ppt/slides/slide13.xml><?xml version="1.0" encoding="utf-8"?>
+<p:sld xmlns:a="http://schemas.openxmlformats.org/drawingml/2006/main" xmlns:p="http://schemas.openxmlformats.org/presentationml/2006/main" xmlns:r="http://schemas.openxmlformats.org/officeDocument/2006/relationships">
+  <p:cSld>
+    <p:spTree>
+      <p:nvGrpSpPr>
+        <p:cNvPr id="1" name=""/>
+        <p:cNvGrpSpPr/>
+        <p:nvPr/>
+      </p:nvGrpSpPr>
+      <p:grpSpPr/>
+      <p:sp>
+        <p:nvSpPr>
+          <p:cNvPr id="2" name="Rectangle 1"/>
+          <p:cNvSpPr/>
+          <p:nvPr/>
+        </p:nvSpPr>
+        <p:spPr>
+          <a:xfrm>
+            <a:off x="0" y="0"/>
+            <a:ext cx="12188952" cy="6858000"/>
+          </a:xfrm>
+          <a:prstGeom prst="rect">
+            <a:avLst/>
+          </a:prstGeom>
+          <a:solidFill>
+            <a:srgbClr val="EDEDF3"/>
+          </a:solidFill>
+          <a:ln>
+            <a:noFill/>
+          </a:ln>
+        </p:spPr>
+        <p:style>
+          <a:lnRef idx="1">
+            <a:schemeClr val="accent1"/>
+          </a:lnRef>
+          <a:fillRef idx="3">
+            <a:schemeClr val="accent1"/>
+          </a:fillRef>
+          <a:effectRef idx="2">
+            <a:schemeClr val="accent1"/>
+          </a:effectRef>
+          <a:fontRef idx="minor">
+            <a:schemeClr val="lt1"/>
+          </a:fontRef>
+        </p:style>
+        <p:txBody>
+          <a:bodyPr rtlCol="0" anchor="ctr"/>
+          <a:lstStyle/>
+          <a:p>
+            <a:pPr algn="ctr"/>
+          </a:p>
+        </p:txBody>
+      </p:sp>
+      <p:sp>
+        <p:nvSpPr>
+          <p:cNvPr id="3" name="Rectangle 2"/>
+          <p:cNvSpPr/>
+          <p:nvPr/>
+        </p:nvSpPr>
+        <p:spPr>
+          <a:xfrm>
+            <a:off x="0" y="0"/>
+            <a:ext cx="12188952" cy="50292"/>
+          </a:xfrm>
+          <a:prstGeom prst="rect">
+            <a:avLst/>
+          </a:prstGeom>
+          <a:solidFill>
+            <a:srgbClr val="1F2C56"/>
+          </a:solidFill>
+          <a:ln>
+            <a:noFill/>
+          </a:ln>
+        </p:spPr>
+        <p:style>
+          <a:lnRef idx="1">
+            <a:schemeClr val="accent1"/>
+          </a:lnRef>
+          <a:fillRef idx="3">
+            <a:schemeClr val="accent1"/>
+          </a:fillRef>
+          <a:effectRef idx="2">
+            <a:schemeClr val="accent1"/>
+          </a:effectRef>
+          <a:fontRef idx="minor">
+            <a:schemeClr val="lt1"/>
+          </a:fontRef>
+        </p:style>
+        <p:txBody>
+          <a:bodyPr rtlCol="0" anchor="ctr"/>
+          <a:lstStyle/>
+          <a:p>
+            <a:pPr algn="ctr"/>
+          </a:p>
+        </p:txBody>
+      </p:sp>
+      <p:sp>
+        <p:nvSpPr>
+          <p:cNvPr id="4" name="TextBox 3"/>
+          <p:cNvSpPr txBox="1"/>
+          <p:nvPr/>
+        </p:nvSpPr>
+        <p:spPr>
+          <a:xfrm>
+            <a:off x="685800" y="109728"/>
+            <a:ext cx="10817352" cy="228600"/>
+          </a:xfrm>
+          <a:prstGeom prst="rect">
+            <a:avLst/>
+          </a:prstGeom>
+          <a:noFill/>
+        </p:spPr>
+        <p:txBody>
+          <a:bodyPr wrap="none">
+            <a:spAutoFit/>
+          </a:bodyPr>
+          <a:lstStyle/>
+          <a:p>
+            <a:pPr algn="l"/>
+            <a:r>
+              <a:rPr sz="750">
+                <a:solidFill>
+                  <a:srgbClr val="78808C"/>
+                </a:solidFill>
+                <a:latin typeface="Consolas"/>
+              </a:rPr>
+              <a:t>VA11  ·  INHALT</a:t>
+            </a:r>
+          </a:p>
+        </p:txBody>
+      </p:sp>
+      <p:sp>
+        <p:nvSpPr>
+          <p:cNvPr id="5" name="Rectangle 4"/>
+          <p:cNvSpPr/>
+          <p:nvPr/>
+        </p:nvSpPr>
+        <p:spPr>
+          <a:xfrm>
+            <a:off x="0" y="1234440"/>
+            <a:ext cx="12188952" cy="12700"/>
+          </a:xfrm>
+          <a:prstGeom prst="rect">
+            <a:avLst/>
+          </a:prstGeom>
+          <a:solidFill>
+            <a:srgbClr val="D8DFE4"/>
+          </a:solidFill>
+          <a:ln>
+            <a:noFill/>
+          </a:ln>
+        </p:spPr>
+        <p:style>
+          <a:lnRef idx="1">
+            <a:schemeClr val="accent1"/>
+          </a:lnRef>
+          <a:fillRef idx="3">
+            <a:schemeClr val="accent1"/>
+          </a:fillRef>
+          <a:effectRef idx="2">
+            <a:schemeClr val="accent1"/>
+          </a:effectRef>
+          <a:fontRef idx="minor">
+            <a:schemeClr val="lt1"/>
+          </a:fontRef>
+        </p:style>
+        <p:txBody>
+          <a:bodyPr rtlCol="0" anchor="ctr"/>
+          <a:lstStyle/>
+          <a:p>
+            <a:pPr algn="ctr"/>
+          </a:p>
+        </p:txBody>
+      </p:sp>
+      <p:sp>
+        <p:nvSpPr>
+          <p:cNvPr id="6" name="Rectangle 5"/>
+          <p:cNvSpPr/>
+          <p:nvPr/>
+        </p:nvSpPr>
+        <p:spPr>
+          <a:xfrm>
+            <a:off x="685800" y="502920"/>
+            <a:ext cx="36576" cy="658368"/>
+          </a:xfrm>
+          <a:prstGeom prst="rect">
+            <a:avLst/>
+          </a:prstGeom>
+          <a:solidFill>
+            <a:srgbClr val="D9C089"/>
+          </a:solidFill>
+          <a:ln>
+            <a:noFill/>
+          </a:ln>
+        </p:spPr>
+        <p:style>
+          <a:lnRef idx="1">
+            <a:schemeClr val="accent1"/>
+          </a:lnRef>
+          <a:fillRef idx="3">
+            <a:schemeClr val="accent1"/>
+          </a:fillRef>
+          <a:effectRef idx="2">
+            <a:schemeClr val="accent1"/>
+          </a:effectRef>
+          <a:fontRef idx="minor">
+            <a:schemeClr val="lt1"/>
+          </a:fontRef>
+        </p:style>
+        <p:txBody>
+          <a:bodyPr rtlCol="0" anchor="ctr"/>
+          <a:lstStyle/>
+          <a:p>
+            <a:pPr algn="ctr"/>
+          </a:p>
+        </p:txBody>
+      </p:sp>
+      <p:sp>
+        <p:nvSpPr>
+          <p:cNvPr id="7" name="TextBox 6"/>
+          <p:cNvSpPr txBox="1"/>
+          <p:nvPr/>
+        </p:nvSpPr>
+        <p:spPr>
+          <a:xfrm>
+            <a:off x="813816" y="502920"/>
+            <a:ext cx="10634472" cy="685800"/>
+          </a:xfrm>
+          <a:prstGeom prst="rect">
+            <a:avLst/>
+          </a:prstGeom>
+          <a:noFill/>
+        </p:spPr>
+        <p:txBody>
+          <a:bodyPr wrap="square">
+            <a:spAutoFit/>
+          </a:bodyPr>
+          <a:lstStyle/>
+          <a:p>
+            <a:pPr algn="l"/>
+            <a:r>
+              <a:rPr sz="2400" b="1" i="0">
+                <a:solidFill>
+                  <a:srgbClr val="1F2C56"/>
+                </a:solidFill>
+                <a:latin typeface="Arial"/>
+              </a:rPr>
+              <a:t>Handlungsempfehlung: Struktur, Verdacht, Standhaftigkeit</a:t>
+            </a:r>
+          </a:p>
+        </p:txBody>
+      </p:sp>
+      <p:sp>
+        <p:nvSpPr>
+          <p:cNvPr id="8" name="TextBox 7"/>
+          <p:cNvSpPr txBox="1"/>
+          <p:nvPr/>
+        </p:nvSpPr>
+        <p:spPr>
+          <a:xfrm>
+            <a:off x="685800" y="1417320"/>
+            <a:ext cx="10817352" cy="4892040"/>
+          </a:xfrm>
+          <a:prstGeom prst="rect">
+            <a:avLst/>
+          </a:prstGeom>
+          <a:noFill/>
+        </p:spPr>
+        <p:txBody>
+          <a:bodyPr wrap="square" anchor="ctr">
+            <a:spAutoFit/>
+          </a:bodyPr>
+          <a:lstStyle/>
+          <a:p>
+            <a:pPr marL="177800" indent="-177800">
+              <a:spcBef>
+                <a:spcPts val="600"/>
+              </a:spcBef>
+              <a:spcAft>
+                <a:spcPts val="200"/>
+              </a:spcAft>
+            </a:pPr>
+            <a:r>
+              <a:rPr sz="1200" i="1">
+                <a:solidFill>
+                  <a:srgbClr val="3D5466"/>
+                </a:solidFill>
+                <a:latin typeface="Arial"/>
+              </a:rPr>
+              <a:t>→  Wenn mehrere Gesellschaften eines Inhabers im Bestand geführt werden — dann mit dem Berater die Kreditnehmereinheit nach § 19 Abs. 2 KWG klären und alle Engagements unter derselben Einheit erfassen.</a:t>
+            </a:r>
+          </a:p>
+          <a:p>
+            <a:pPr marL="177800" indent="-177800">
+              <a:spcBef>
+                <a:spcPts val="600"/>
+              </a:spcBef>
+              <a:spcAft>
+                <a:spcPts val="200"/>
+              </a:spcAft>
+            </a:pPr>
+            <a:r>
+              <a:rPr sz="1200" i="1">
+                <a:solidFill>
+                  <a:srgbClr val="3D5466"/>
+                </a:solidFill>
+                <a:latin typeface="Arial"/>
+              </a:rPr>
+              <a:t>→  Wenn ein Verdachtsmoment wahrgenommen wird — dann dokumentieren, nichts ändern, den Geldwäschebeauftragten informieren und den Kunden NICHT ansprechen (Tipping-off).</a:t>
+            </a:r>
+          </a:p>
+          <a:p>
+            <a:pPr marL="177800" indent="-177800">
+              <a:spcBef>
+                <a:spcPts val="600"/>
+              </a:spcBef>
+              <a:spcAft>
+                <a:spcPts val="200"/>
+              </a:spcAft>
+            </a:pPr>
+            <a:r>
+              <a:rPr sz="1200" i="1">
+                <a:solidFill>
+                  <a:srgbClr val="3D5466"/>
+                </a:solidFill>
+                <a:latin typeface="Arial"/>
+              </a:rPr>
+              <a:t>→  Wenn der Berater Druck macht, trotz Verdacht „einfach durchzuführen" — dann freundlich, aber bestimmt auf Rücksprache mit dem Geldwäschebeauftragten bestehen; im Zweifel die Teamleitung hinzuziehen.</a:t>
+            </a:r>
+          </a:p>
+        </p:txBody>
+      </p:sp>
+      <p:sp>
+        <p:nvSpPr>
+          <p:cNvPr id="9" name="Rectangle 8"/>
+          <p:cNvSpPr/>
+          <p:nvPr/>
+        </p:nvSpPr>
+        <p:spPr>
+          <a:xfrm>
+            <a:off x="0" y="6510528"/>
+            <a:ext cx="12188952" cy="347472"/>
+          </a:xfrm>
+          <a:prstGeom prst="rect">
+            <a:avLst/>
+          </a:prstGeom>
+          <a:solidFill>
+            <a:srgbClr val="0A1937"/>
+          </a:solidFill>
+          <a:ln>
+            <a:noFill/>
+          </a:ln>
+        </p:spPr>
+        <p:style>
+          <a:lnRef idx="1">
+            <a:schemeClr val="accent1"/>
+          </a:lnRef>
+          <a:fillRef idx="3">
+            <a:schemeClr val="accent1"/>
+          </a:fillRef>
+          <a:effectRef idx="2">
+            <a:schemeClr val="accent1"/>
+          </a:effectRef>
+          <a:fontRef idx="minor">
+            <a:schemeClr val="lt1"/>
+          </a:fontRef>
+        </p:style>
+        <p:txBody>
+          <a:bodyPr rtlCol="0" anchor="ctr"/>
+          <a:lstStyle/>
+          <a:p>
+            <a:pPr algn="ctr"/>
+          </a:p>
+        </p:txBody>
+      </p:sp>
+      <p:sp>
+        <p:nvSpPr>
+          <p:cNvPr id="10" name="TextBox 9"/>
+          <p:cNvSpPr txBox="1"/>
+          <p:nvPr/>
+        </p:nvSpPr>
+        <p:spPr>
+          <a:xfrm>
+            <a:off x="685800" y="6583680"/>
+            <a:ext cx="6490411" cy="256032"/>
+          </a:xfrm>
+          <a:prstGeom prst="rect">
+            <a:avLst/>
+          </a:prstGeom>
+          <a:noFill/>
+        </p:spPr>
+        <p:txBody>
+          <a:bodyPr wrap="none">
+            <a:spAutoFit/>
+          </a:bodyPr>
+          <a:lstStyle/>
+          <a:p>
+            <a:pPr algn="l"/>
+            <a:r>
+              <a:rPr sz="700">
+                <a:solidFill>
+                  <a:srgbClr val="A0B4D2"/>
+                </a:solidFill>
+                <a:latin typeface="Consolas"/>
+              </a:rPr>
+              <a:t>FKB Campus  ·  VA11</a:t>
+            </a:r>
+          </a:p>
+        </p:txBody>
+      </p:sp>
+    </p:spTree>
+  </p:cSld>
+  <p:clrMapOvr>
+    <a:masterClrMapping/>
+  </p:clrMapOvr>
+</p:sld>
+</file>
+
+<file path=ppt/slides/slide14.xml><?xml version="1.0" encoding="utf-8"?>
+<p:sld xmlns:a="http://schemas.openxmlformats.org/drawingml/2006/main" xmlns:p="http://schemas.openxmlformats.org/presentationml/2006/main" xmlns:r="http://schemas.openxmlformats.org/officeDocument/2006/relationships">
+  <p:cSld>
+    <p:spTree>
+      <p:nvGrpSpPr>
+        <p:cNvPr id="1" name=""/>
+        <p:cNvGrpSpPr/>
+        <p:nvPr/>
+      </p:nvGrpSpPr>
+      <p:grpSpPr/>
+      <p:sp>
+        <p:nvSpPr>
+          <p:cNvPr id="2" name="Rectangle 1"/>
+          <p:cNvSpPr/>
+          <p:nvPr/>
+        </p:nvSpPr>
+        <p:spPr>
+          <a:xfrm>
+            <a:off x="0" y="0"/>
+            <a:ext cx="12188952" cy="6858000"/>
+          </a:xfrm>
+          <a:prstGeom prst="rect">
+            <a:avLst/>
+          </a:prstGeom>
+          <a:solidFill>
+            <a:srgbClr val="EDEDF3"/>
+          </a:solidFill>
+          <a:ln>
+            <a:noFill/>
+          </a:ln>
+        </p:spPr>
+        <p:style>
+          <a:lnRef idx="1">
+            <a:schemeClr val="accent1"/>
+          </a:lnRef>
+          <a:fillRef idx="3">
+            <a:schemeClr val="accent1"/>
+          </a:fillRef>
+          <a:effectRef idx="2">
+            <a:schemeClr val="accent1"/>
+          </a:effectRef>
+          <a:fontRef idx="minor">
+            <a:schemeClr val="lt1"/>
+          </a:fontRef>
+        </p:style>
+        <p:txBody>
+          <a:bodyPr rtlCol="0" anchor="ctr"/>
+          <a:lstStyle/>
+          <a:p>
+            <a:pPr algn="ctr"/>
+          </a:p>
+        </p:txBody>
+      </p:sp>
+      <p:sp>
+        <p:nvSpPr>
+          <p:cNvPr id="3" name="Rectangle 2"/>
+          <p:cNvSpPr/>
+          <p:nvPr/>
+        </p:nvSpPr>
+        <p:spPr>
+          <a:xfrm>
+            <a:off x="0" y="0"/>
+            <a:ext cx="12188952" cy="50292"/>
+          </a:xfrm>
+          <a:prstGeom prst="rect">
+            <a:avLst/>
+          </a:prstGeom>
+          <a:solidFill>
+            <a:srgbClr val="1F2C56"/>
+          </a:solidFill>
+          <a:ln>
+            <a:noFill/>
+          </a:ln>
+        </p:spPr>
+        <p:style>
+          <a:lnRef idx="1">
+            <a:schemeClr val="accent1"/>
+          </a:lnRef>
+          <a:fillRef idx="3">
+            <a:schemeClr val="accent1"/>
+          </a:fillRef>
+          <a:effectRef idx="2">
+            <a:schemeClr val="accent1"/>
+          </a:effectRef>
+          <a:fontRef idx="minor">
+            <a:schemeClr val="lt1"/>
+          </a:fontRef>
+        </p:style>
+        <p:txBody>
+          <a:bodyPr rtlCol="0" anchor="ctr"/>
+          <a:lstStyle/>
+          <a:p>
+            <a:pPr algn="ctr"/>
+          </a:p>
+        </p:txBody>
+      </p:sp>
+      <p:sp>
+        <p:nvSpPr>
+          <p:cNvPr id="4" name="TextBox 3"/>
+          <p:cNvSpPr txBox="1"/>
+          <p:nvPr/>
+        </p:nvSpPr>
+        <p:spPr>
+          <a:xfrm>
+            <a:off x="685800" y="109728"/>
+            <a:ext cx="10817352" cy="228600"/>
+          </a:xfrm>
+          <a:prstGeom prst="rect">
+            <a:avLst/>
+          </a:prstGeom>
+          <a:noFill/>
+        </p:spPr>
+        <p:txBody>
+          <a:bodyPr wrap="none">
+            <a:spAutoFit/>
+          </a:bodyPr>
+          <a:lstStyle/>
+          <a:p>
+            <a:pPr algn="l"/>
+            <a:r>
+              <a:rPr sz="750">
+                <a:solidFill>
+                  <a:srgbClr val="78808C"/>
+                </a:solidFill>
+                <a:latin typeface="Consolas"/>
+              </a:rPr>
+              <a:t>VA11  ·  ARBEITSBLATT</a:t>
+            </a:r>
+          </a:p>
+        </p:txBody>
+      </p:sp>
+      <p:sp>
+        <p:nvSpPr>
+          <p:cNvPr id="5" name="Rectangle 4"/>
+          <p:cNvSpPr/>
+          <p:nvPr/>
+        </p:nvSpPr>
+        <p:spPr>
+          <a:xfrm>
+            <a:off x="0" y="1234440"/>
+            <a:ext cx="12188952" cy="12700"/>
+          </a:xfrm>
+          <a:prstGeom prst="rect">
+            <a:avLst/>
+          </a:prstGeom>
+          <a:solidFill>
+            <a:srgbClr val="D8DFE4"/>
+          </a:solidFill>
+          <a:ln>
+            <a:noFill/>
+          </a:ln>
+        </p:spPr>
+        <p:style>
+          <a:lnRef idx="1">
+            <a:schemeClr val="accent1"/>
+          </a:lnRef>
+          <a:fillRef idx="3">
+            <a:schemeClr val="accent1"/>
+          </a:fillRef>
+          <a:effectRef idx="2">
+            <a:schemeClr val="accent1"/>
+          </a:effectRef>
+          <a:fontRef idx="minor">
+            <a:schemeClr val="lt1"/>
+          </a:fontRef>
+        </p:style>
+        <p:txBody>
+          <a:bodyPr rtlCol="0" anchor="ctr"/>
+          <a:lstStyle/>
+          <a:p>
+            <a:pPr algn="ctr"/>
+          </a:p>
+        </p:txBody>
+      </p:sp>
+      <p:sp>
+        <p:nvSpPr>
+          <p:cNvPr id="6" name="Rectangle 5"/>
+          <p:cNvSpPr/>
+          <p:nvPr/>
+        </p:nvSpPr>
+        <p:spPr>
+          <a:xfrm>
+            <a:off x="685800" y="502920"/>
+            <a:ext cx="36576" cy="658368"/>
+          </a:xfrm>
+          <a:prstGeom prst="rect">
+            <a:avLst/>
+          </a:prstGeom>
+          <a:solidFill>
+            <a:srgbClr val="D9C089"/>
+          </a:solidFill>
+          <a:ln>
+            <a:noFill/>
+          </a:ln>
+        </p:spPr>
+        <p:style>
+          <a:lnRef idx="1">
+            <a:schemeClr val="accent1"/>
+          </a:lnRef>
+          <a:fillRef idx="3">
+            <a:schemeClr val="accent1"/>
+          </a:fillRef>
+          <a:effectRef idx="2">
+            <a:schemeClr val="accent1"/>
+          </a:effectRef>
+          <a:fontRef idx="minor">
+            <a:schemeClr val="lt1"/>
+          </a:fontRef>
+        </p:style>
+        <p:txBody>
+          <a:bodyPr rtlCol="0" anchor="ctr"/>
+          <a:lstStyle/>
+          <a:p>
+            <a:pPr algn="ctr"/>
+          </a:p>
+        </p:txBody>
+      </p:sp>
+      <p:sp>
+        <p:nvSpPr>
+          <p:cNvPr id="7" name="TextBox 6"/>
+          <p:cNvSpPr txBox="1"/>
+          <p:nvPr/>
+        </p:nvSpPr>
+        <p:spPr>
+          <a:xfrm>
+            <a:off x="813816" y="502920"/>
+            <a:ext cx="10634472" cy="685800"/>
+          </a:xfrm>
+          <a:prstGeom prst="rect">
+            <a:avLst/>
+          </a:prstGeom>
+          <a:noFill/>
+        </p:spPr>
+        <p:txBody>
+          <a:bodyPr wrap="square">
+            <a:spAutoFit/>
+          </a:bodyPr>
+          <a:lstStyle/>
+          <a:p>
+            <a:pPr algn="l"/>
+            <a:r>
+              <a:rPr sz="2400" b="1" i="0">
+                <a:solidFill>
+                  <a:srgbClr val="1F2C56"/>
+                </a:solidFill>
+                <a:latin typeface="Arial"/>
+              </a:rPr>
+              <a:t>Praxisfall bearbeiten: Einheit, wB, Verdacht</a:t>
+            </a:r>
+          </a:p>
+        </p:txBody>
+      </p:sp>
+      <p:sp>
+        <p:nvSpPr>
+          <p:cNvPr id="8" name="TextBox 7"/>
+          <p:cNvSpPr txBox="1"/>
+          <p:nvPr/>
+        </p:nvSpPr>
+        <p:spPr>
+          <a:xfrm>
+            <a:off x="685800" y="1554480"/>
+            <a:ext cx="10817352" cy="3840480"/>
+          </a:xfrm>
+          <a:prstGeom prst="rect">
+            <a:avLst/>
+          </a:prstGeom>
+          <a:noFill/>
+        </p:spPr>
+        <p:txBody>
+          <a:bodyPr wrap="square">
+            <a:spAutoFit/>
+          </a:bodyPr>
+          <a:lstStyle/>
+          <a:p>
+            <a:pPr marL="190500" indent="-190500">
+              <a:spcBef>
+                <a:spcPts val="400"/>
+              </a:spcBef>
+              <a:spcAft>
+                <a:spcPts val="200"/>
+              </a:spcAft>
+            </a:pPr>
+            <a:r>
+              <a:rPr sz="1400">
+                <a:solidFill>
+                  <a:srgbClr val="3D5466"/>
+                </a:solidFill>
+                <a:latin typeface="Arial"/>
+              </a:rPr>
+              <a:t>▸  Bilden Sie die Kreditnehmereinheit aus dem Organigramm (AB-1).</a:t>
+            </a:r>
+          </a:p>
+          <a:p>
+            <a:pPr marL="190500" indent="-190500">
+              <a:spcBef>
+                <a:spcPts val="400"/>
+              </a:spcBef>
+              <a:spcAft>
+                <a:spcPts val="200"/>
+              </a:spcAft>
+            </a:pPr>
+            <a:r>
+              <a:rPr sz="1400">
+                <a:solidFill>
+                  <a:srgbClr val="3D5466"/>
+                </a:solidFill>
+                <a:latin typeface="Arial"/>
+              </a:rPr>
+              <a:t>▸  Ermitteln Sie den wirtschaftlich Berechtigten durch Durchrechnen der Ketten (AB-2).</a:t>
+            </a:r>
+          </a:p>
+          <a:p>
+            <a:pPr marL="190500" indent="-190500">
+              <a:spcBef>
+                <a:spcPts val="400"/>
+              </a:spcBef>
+              <a:spcAft>
+                <a:spcPts val="200"/>
+              </a:spcAft>
+            </a:pPr>
+            <a:r>
+              <a:rPr sz="1400">
+                <a:solidFill>
+                  <a:srgbClr val="3D5466"/>
+                </a:solidFill>
+                <a:latin typeface="Arial"/>
+              </a:rPr>
+              <a:t>▸  Ordnen Sie Kreditnehmereinheit und Betreuungseinheit korrekt zu (AB-3).</a:t>
+            </a:r>
+          </a:p>
+          <a:p>
+            <a:pPr marL="190500" indent="-190500">
+              <a:spcBef>
+                <a:spcPts val="400"/>
+              </a:spcBef>
+              <a:spcAft>
+                <a:spcPts val="200"/>
+              </a:spcAft>
+            </a:pPr>
+            <a:r>
+              <a:rPr sz="1400">
+                <a:solidFill>
+                  <a:srgbClr val="3D5466"/>
+                </a:solidFill>
+                <a:latin typeface="Arial"/>
+              </a:rPr>
+              <a:t>▸  Analysieren Sie die Verdachtsszenarien A und B (AB-4) – Prüfkarte AB-5 als Werkzeug.</a:t>
+            </a:r>
+          </a:p>
+        </p:txBody>
+      </p:sp>
+      <p:sp>
+        <p:nvSpPr>
+          <p:cNvPr id="9" name="Rectangle 8"/>
+          <p:cNvSpPr/>
+          <p:nvPr/>
+        </p:nvSpPr>
+        <p:spPr>
+          <a:xfrm>
+            <a:off x="685800" y="5486400"/>
+            <a:ext cx="10817352" cy="640080"/>
+          </a:xfrm>
+          <a:prstGeom prst="rect">
+            <a:avLst/>
+          </a:prstGeom>
+          <a:solidFill>
+            <a:srgbClr val="1F2C56"/>
+          </a:solidFill>
+          <a:ln>
+            <a:noFill/>
+          </a:ln>
+        </p:spPr>
+        <p:style>
+          <a:lnRef idx="1">
+            <a:schemeClr val="accent1"/>
+          </a:lnRef>
+          <a:fillRef idx="3">
+            <a:schemeClr val="accent1"/>
+          </a:fillRef>
+          <a:effectRef idx="2">
+            <a:schemeClr val="accent1"/>
+          </a:effectRef>
+          <a:fontRef idx="minor">
+            <a:schemeClr val="lt1"/>
+          </a:fontRef>
+        </p:style>
+        <p:txBody>
+          <a:bodyPr rtlCol="0" anchor="ctr"/>
+          <a:lstStyle/>
+          <a:p>
+            <a:pPr algn="ctr"/>
+          </a:p>
+        </p:txBody>
+      </p:sp>
+      <p:sp>
+        <p:nvSpPr>
+          <p:cNvPr id="10" name="TextBox 9"/>
+          <p:cNvSpPr txBox="1"/>
+          <p:nvPr/>
+        </p:nvSpPr>
+        <p:spPr>
+          <a:xfrm>
+            <a:off x="868680" y="5596128"/>
+            <a:ext cx="10451592" cy="457200"/>
+          </a:xfrm>
+          <a:prstGeom prst="rect">
+            <a:avLst/>
+          </a:prstGeom>
+          <a:noFill/>
+        </p:spPr>
+        <p:txBody>
+          <a:bodyPr wrap="square">
+            <a:spAutoFit/>
+          </a:bodyPr>
+          <a:lstStyle/>
+          <a:p>
+            <a:pPr algn="l"/>
+            <a:r>
+              <a:rPr sz="1300" b="1" i="0">
+                <a:solidFill>
+                  <a:srgbClr val="FFFFFF"/>
+                </a:solidFill>
+                <a:latin typeface="Arial"/>
+              </a:rPr>
+              <a:t>→  Bearbeitung im Teilnehmer-Workbook (Arbeitsblatt mit Ausfüllfeldern)</a:t>
+            </a:r>
+          </a:p>
+        </p:txBody>
+      </p:sp>
+      <p:sp>
+        <p:nvSpPr>
+          <p:cNvPr id="11" name="Rectangle 10"/>
+          <p:cNvSpPr/>
+          <p:nvPr/>
+        </p:nvSpPr>
+        <p:spPr>
+          <a:xfrm>
+            <a:off x="0" y="6510528"/>
+            <a:ext cx="12188952" cy="347472"/>
+          </a:xfrm>
+          <a:prstGeom prst="rect">
+            <a:avLst/>
+          </a:prstGeom>
+          <a:solidFill>
+            <a:srgbClr val="0A1937"/>
+          </a:solidFill>
+          <a:ln>
+            <a:noFill/>
+          </a:ln>
+        </p:spPr>
+        <p:style>
+          <a:lnRef idx="1">
+            <a:schemeClr val="accent1"/>
+          </a:lnRef>
+          <a:fillRef idx="3">
+            <a:schemeClr val="accent1"/>
+          </a:fillRef>
+          <a:effectRef idx="2">
+            <a:schemeClr val="accent1"/>
+          </a:effectRef>
+          <a:fontRef idx="minor">
+            <a:schemeClr val="lt1"/>
+          </a:fontRef>
+        </p:style>
+        <p:txBody>
+          <a:bodyPr rtlCol="0" anchor="ctr"/>
+          <a:lstStyle/>
+          <a:p>
+            <a:pPr algn="ctr"/>
+          </a:p>
+        </p:txBody>
+      </p:sp>
+      <p:sp>
+        <p:nvSpPr>
+          <p:cNvPr id="12" name="TextBox 11"/>
+          <p:cNvSpPr txBox="1"/>
+          <p:nvPr/>
+        </p:nvSpPr>
+        <p:spPr>
+          <a:xfrm>
+            <a:off x="685800" y="6583680"/>
+            <a:ext cx="6490411" cy="256032"/>
+          </a:xfrm>
+          <a:prstGeom prst="rect">
+            <a:avLst/>
+          </a:prstGeom>
+          <a:noFill/>
+        </p:spPr>
+        <p:txBody>
+          <a:bodyPr wrap="none">
+            <a:spAutoFit/>
+          </a:bodyPr>
+          <a:lstStyle/>
+          <a:p>
+            <a:pPr algn="l"/>
+            <a:r>
+              <a:rPr sz="700">
+                <a:solidFill>
+                  <a:srgbClr val="A0B4D2"/>
+                </a:solidFill>
+                <a:latin typeface="Consolas"/>
+              </a:rPr>
+              <a:t>FKB Campus  ·  VA11</a:t>
+            </a:r>
+          </a:p>
+        </p:txBody>
+      </p:sp>
+    </p:spTree>
+  </p:cSld>
+  <p:clrMapOvr>
+    <a:masterClrMapping/>
+  </p:clrMapOvr>
+</p:sld>
+</file>
+
+<file path=ppt/slides/slide15.xml><?xml version="1.0" encoding="utf-8"?>
+<p:sld xmlns:a="http://schemas.openxmlformats.org/drawingml/2006/main" xmlns:p="http://schemas.openxmlformats.org/presentationml/2006/main" xmlns:r="http://schemas.openxmlformats.org/officeDocument/2006/relationships">
+  <p:cSld>
+    <p:spTree>
+      <p:nvGrpSpPr>
+        <p:cNvPr id="1" name=""/>
+        <p:cNvGrpSpPr/>
+        <p:nvPr/>
+      </p:nvGrpSpPr>
+      <p:grpSpPr/>
+      <p:sp>
+        <p:nvSpPr>
+          <p:cNvPr id="2" name="Rectangle 1"/>
+          <p:cNvSpPr/>
+          <p:nvPr/>
+        </p:nvSpPr>
+        <p:spPr>
+          <a:xfrm>
+            <a:off x="0" y="0"/>
+            <a:ext cx="12188952" cy="6858000"/>
+          </a:xfrm>
+          <a:prstGeom prst="rect">
+            <a:avLst/>
+          </a:prstGeom>
+          <a:solidFill>
+            <a:srgbClr val="EDEDF3"/>
+          </a:solidFill>
+          <a:ln>
+            <a:noFill/>
+          </a:ln>
+        </p:spPr>
+        <p:style>
+          <a:lnRef idx="1">
+            <a:schemeClr val="accent1"/>
+          </a:lnRef>
+          <a:fillRef idx="3">
+            <a:schemeClr val="accent1"/>
+          </a:fillRef>
+          <a:effectRef idx="2">
+            <a:schemeClr val="accent1"/>
+          </a:effectRef>
+          <a:fontRef idx="minor">
+            <a:schemeClr val="lt1"/>
+          </a:fontRef>
+        </p:style>
+        <p:txBody>
+          <a:bodyPr rtlCol="0" anchor="ctr"/>
+          <a:lstStyle/>
+          <a:p>
+            <a:pPr algn="ctr"/>
+          </a:p>
+        </p:txBody>
+      </p:sp>
+      <p:sp>
+        <p:nvSpPr>
+          <p:cNvPr id="3" name="Rectangle 2"/>
+          <p:cNvSpPr/>
+          <p:nvPr/>
+        </p:nvSpPr>
+        <p:spPr>
+          <a:xfrm>
+            <a:off x="0" y="0"/>
+            <a:ext cx="12188952" cy="50292"/>
+          </a:xfrm>
+          <a:prstGeom prst="rect">
+            <a:avLst/>
+          </a:prstGeom>
+          <a:solidFill>
+            <a:srgbClr val="1F2C56"/>
+          </a:solidFill>
+          <a:ln>
+            <a:noFill/>
+          </a:ln>
+        </p:spPr>
+        <p:style>
+          <a:lnRef idx="1">
+            <a:schemeClr val="accent1"/>
+          </a:lnRef>
+          <a:fillRef idx="3">
+            <a:schemeClr val="accent1"/>
+          </a:fillRef>
+          <a:effectRef idx="2">
+            <a:schemeClr val="accent1"/>
+          </a:effectRef>
+          <a:fontRef idx="minor">
+            <a:schemeClr val="lt1"/>
+          </a:fontRef>
+        </p:style>
+        <p:txBody>
+          <a:bodyPr rtlCol="0" anchor="ctr"/>
+          <a:lstStyle/>
+          <a:p>
+            <a:pPr algn="ctr"/>
+          </a:p>
+        </p:txBody>
+      </p:sp>
+      <p:sp>
+        <p:nvSpPr>
+          <p:cNvPr id="4" name="TextBox 3"/>
+          <p:cNvSpPr txBox="1"/>
+          <p:nvPr/>
+        </p:nvSpPr>
+        <p:spPr>
+          <a:xfrm>
+            <a:off x="685800" y="109728"/>
+            <a:ext cx="10817352" cy="228600"/>
+          </a:xfrm>
+          <a:prstGeom prst="rect">
+            <a:avLst/>
+          </a:prstGeom>
+          <a:noFill/>
+        </p:spPr>
+        <p:txBody>
+          <a:bodyPr wrap="none">
+            <a:spAutoFit/>
+          </a:bodyPr>
+          <a:lstStyle/>
+          <a:p>
+            <a:pPr algn="l"/>
+            <a:r>
+              <a:rPr sz="750">
+                <a:solidFill>
+                  <a:srgbClr val="78808C"/>
+                </a:solidFill>
+                <a:latin typeface="Consolas"/>
+              </a:rPr>
+              <a:t>VA11  ·  INHALT</a:t>
+            </a:r>
+          </a:p>
+        </p:txBody>
+      </p:sp>
+      <p:sp>
+        <p:nvSpPr>
+          <p:cNvPr id="5" name="Rectangle 4"/>
+          <p:cNvSpPr/>
+          <p:nvPr/>
+        </p:nvSpPr>
+        <p:spPr>
+          <a:xfrm>
+            <a:off x="0" y="1234440"/>
+            <a:ext cx="12188952" cy="12700"/>
+          </a:xfrm>
+          <a:prstGeom prst="rect">
+            <a:avLst/>
+          </a:prstGeom>
+          <a:solidFill>
+            <a:srgbClr val="D8DFE4"/>
+          </a:solidFill>
+          <a:ln>
+            <a:noFill/>
+          </a:ln>
+        </p:spPr>
+        <p:style>
+          <a:lnRef idx="1">
+            <a:schemeClr val="accent1"/>
+          </a:lnRef>
+          <a:fillRef idx="3">
+            <a:schemeClr val="accent1"/>
+          </a:fillRef>
+          <a:effectRef idx="2">
+            <a:schemeClr val="accent1"/>
+          </a:effectRef>
+          <a:fontRef idx="minor">
+            <a:schemeClr val="lt1"/>
+          </a:fontRef>
+        </p:style>
+        <p:txBody>
+          <a:bodyPr rtlCol="0" anchor="ctr"/>
+          <a:lstStyle/>
+          <a:p>
+            <a:pPr algn="ctr"/>
+          </a:p>
+        </p:txBody>
+      </p:sp>
+      <p:sp>
+        <p:nvSpPr>
+          <p:cNvPr id="6" name="Rectangle 5"/>
+          <p:cNvSpPr/>
+          <p:nvPr/>
+        </p:nvSpPr>
+        <p:spPr>
+          <a:xfrm>
+            <a:off x="685800" y="502920"/>
+            <a:ext cx="36576" cy="658368"/>
+          </a:xfrm>
+          <a:prstGeom prst="rect">
+            <a:avLst/>
+          </a:prstGeom>
+          <a:solidFill>
+            <a:srgbClr val="D9C089"/>
+          </a:solidFill>
+          <a:ln>
+            <a:noFill/>
+          </a:ln>
+        </p:spPr>
+        <p:style>
+          <a:lnRef idx="1">
+            <a:schemeClr val="accent1"/>
+          </a:lnRef>
+          <a:fillRef idx="3">
+            <a:schemeClr val="accent1"/>
+          </a:fillRef>
+          <a:effectRef idx="2">
+            <a:schemeClr val="accent1"/>
+          </a:effectRef>
+          <a:fontRef idx="minor">
+            <a:schemeClr val="lt1"/>
+          </a:fontRef>
+        </p:style>
+        <p:txBody>
+          <a:bodyPr rtlCol="0" anchor="ctr"/>
+          <a:lstStyle/>
+          <a:p>
+            <a:pPr algn="ctr"/>
+          </a:p>
+        </p:txBody>
+      </p:sp>
+      <p:sp>
+        <p:nvSpPr>
+          <p:cNvPr id="7" name="TextBox 6"/>
+          <p:cNvSpPr txBox="1"/>
+          <p:nvPr/>
+        </p:nvSpPr>
+        <p:spPr>
+          <a:xfrm>
+            <a:off x="813816" y="502920"/>
+            <a:ext cx="10634472" cy="685800"/>
+          </a:xfrm>
+          <a:prstGeom prst="rect">
+            <a:avLst/>
+          </a:prstGeom>
+          <a:noFill/>
+        </p:spPr>
+        <p:txBody>
+          <a:bodyPr wrap="square">
+            <a:spAutoFit/>
+          </a:bodyPr>
+          <a:lstStyle/>
+          <a:p>
+            <a:pPr algn="l"/>
+            <a:r>
+              <a:rPr sz="2400" b="1" i="0">
+                <a:solidFill>
+                  <a:srgbClr val="1F2C56"/>
+                </a:solidFill>
+                <a:latin typeface="Arial"/>
+              </a:rPr>
+              <a:t>Prinzip dieses Moduls</a:t>
+            </a:r>
+          </a:p>
+        </p:txBody>
+      </p:sp>
+      <p:sp>
+        <p:nvSpPr>
+          <p:cNvPr id="8" name="TextBox 7"/>
+          <p:cNvSpPr txBox="1"/>
+          <p:nvPr/>
+        </p:nvSpPr>
+        <p:spPr>
+          <a:xfrm>
+            <a:off x="685800" y="1417320"/>
+            <a:ext cx="10817352" cy="4892040"/>
+          </a:xfrm>
+          <a:prstGeom prst="rect">
+            <a:avLst/>
+          </a:prstGeom>
+          <a:noFill/>
+        </p:spPr>
+        <p:txBody>
+          <a:bodyPr wrap="square" anchor="ctr">
+            <a:spAutoFit/>
+          </a:bodyPr>
+          <a:lstStyle/>
+          <a:p>
+            <a:pPr marL="177800" indent="-177800">
+              <a:spcBef>
+                <a:spcPts val="600"/>
+              </a:spcBef>
+              <a:spcAft>
+                <a:spcPts val="200"/>
+              </a:spcAft>
+            </a:pPr>
+            <a:r>
+              <a:rPr sz="1200" i="1">
+                <a:solidFill>
+                  <a:srgbClr val="3D5466"/>
+                </a:solidFill>
+                <a:latin typeface="Arial"/>
+              </a:rPr>
+              <a:t>→  Wer die Struktur durchschaut, erkennt das Risiko.</a:t>
+            </a:r>
+          </a:p>
+          <a:p>
+            <a:pPr marL="190500" indent="-190500">
+              <a:spcBef>
+                <a:spcPts val="400"/>
+              </a:spcBef>
+              <a:spcAft>
+                <a:spcPts val="200"/>
+              </a:spcAft>
+            </a:pPr>
+            <a:r>
+              <a:rPr sz="1300">
+                <a:solidFill>
+                  <a:srgbClr val="3D5466"/>
+                </a:solidFill>
+                <a:latin typeface="Arial"/>
+              </a:rPr>
+              <a:t>▸  Kreditnehmereinheit und wirtschaftlich Berechtigten über Beteiligungsketten zu ermitteln ist die Grundlage jeder rechtssicheren Entscheidung.</a:t>
+            </a:r>
+          </a:p>
+        </p:txBody>
+      </p:sp>
+      <p:sp>
+        <p:nvSpPr>
+          <p:cNvPr id="9" name="Rectangle 8"/>
+          <p:cNvSpPr/>
+          <p:nvPr/>
+        </p:nvSpPr>
+        <p:spPr>
+          <a:xfrm>
+            <a:off x="0" y="6510528"/>
+            <a:ext cx="12188952" cy="347472"/>
+          </a:xfrm>
+          <a:prstGeom prst="rect">
+            <a:avLst/>
+          </a:prstGeom>
+          <a:solidFill>
+            <a:srgbClr val="0A1937"/>
+          </a:solidFill>
+          <a:ln>
+            <a:noFill/>
+          </a:ln>
+        </p:spPr>
+        <p:style>
+          <a:lnRef idx="1">
+            <a:schemeClr val="accent1"/>
+          </a:lnRef>
+          <a:fillRef idx="3">
+            <a:schemeClr val="accent1"/>
+          </a:fillRef>
+          <a:effectRef idx="2">
+            <a:schemeClr val="accent1"/>
+          </a:effectRef>
+          <a:fontRef idx="minor">
+            <a:schemeClr val="lt1"/>
+          </a:fontRef>
+        </p:style>
+        <p:txBody>
+          <a:bodyPr rtlCol="0" anchor="ctr"/>
+          <a:lstStyle/>
+          <a:p>
+            <a:pPr algn="ctr"/>
+          </a:p>
+        </p:txBody>
+      </p:sp>
+      <p:sp>
+        <p:nvSpPr>
+          <p:cNvPr id="10" name="TextBox 9"/>
+          <p:cNvSpPr txBox="1"/>
+          <p:nvPr/>
+        </p:nvSpPr>
+        <p:spPr>
+          <a:xfrm>
+            <a:off x="685800" y="6583680"/>
+            <a:ext cx="6490411" cy="256032"/>
+          </a:xfrm>
+          <a:prstGeom prst="rect">
+            <a:avLst/>
+          </a:prstGeom>
+          <a:noFill/>
+        </p:spPr>
+        <p:txBody>
+          <a:bodyPr wrap="none">
+            <a:spAutoFit/>
+          </a:bodyPr>
+          <a:lstStyle/>
+          <a:p>
+            <a:pPr algn="l"/>
+            <a:r>
+              <a:rPr sz="700">
+                <a:solidFill>
+                  <a:srgbClr val="A0B4D2"/>
+                </a:solidFill>
+                <a:latin typeface="Consolas"/>
+              </a:rPr>
+              <a:t>FKB Campus  ·  VA11</a:t>
+            </a:r>
+          </a:p>
+        </p:txBody>
+      </p:sp>
+    </p:spTree>
+  </p:cSld>
+  <p:clrMapOvr>
+    <a:masterClrMapping/>
+  </p:clrMapOvr>
+</p:sld>
+</file>
+
+<file path=ppt/slides/slide16.xml><?xml version="1.0" encoding="utf-8"?>
+<p:sld xmlns:a="http://schemas.openxmlformats.org/drawingml/2006/main" xmlns:p="http://schemas.openxmlformats.org/presentationml/2006/main" xmlns:r="http://schemas.openxmlformats.org/officeDocument/2006/relationships">
+  <p:cSld>
+    <p:spTree>
+      <p:nvGrpSpPr>
+        <p:cNvPr id="1" name=""/>
+        <p:cNvGrpSpPr/>
+        <p:nvPr/>
+      </p:nvGrpSpPr>
+      <p:grpSpPr/>
+      <p:sp>
+        <p:nvSpPr>
+          <p:cNvPr id="2" name="Rectangle 1"/>
+          <p:cNvSpPr/>
+          <p:nvPr/>
+        </p:nvSpPr>
+        <p:spPr>
+          <a:xfrm>
+            <a:off x="0" y="0"/>
+            <a:ext cx="12188952" cy="6858000"/>
+          </a:xfrm>
+          <a:prstGeom prst="rect">
+            <a:avLst/>
+          </a:prstGeom>
+          <a:solidFill>
+            <a:srgbClr val="EDEDF3"/>
+          </a:solidFill>
+          <a:ln>
+            <a:noFill/>
+          </a:ln>
+        </p:spPr>
+        <p:style>
+          <a:lnRef idx="1">
+            <a:schemeClr val="accent1"/>
+          </a:lnRef>
+          <a:fillRef idx="3">
+            <a:schemeClr val="accent1"/>
+          </a:fillRef>
+          <a:effectRef idx="2">
+            <a:schemeClr val="accent1"/>
+          </a:effectRef>
+          <a:fontRef idx="minor">
+            <a:schemeClr val="lt1"/>
+          </a:fontRef>
+        </p:style>
+        <p:txBody>
+          <a:bodyPr rtlCol="0" anchor="ctr"/>
+          <a:lstStyle/>
+          <a:p>
+            <a:pPr algn="ctr"/>
+          </a:p>
+        </p:txBody>
+      </p:sp>
+      <p:sp>
+        <p:nvSpPr>
+          <p:cNvPr id="3" name="Rectangle 2"/>
+          <p:cNvSpPr/>
+          <p:nvPr/>
+        </p:nvSpPr>
+        <p:spPr>
+          <a:xfrm>
+            <a:off x="0" y="0"/>
+            <a:ext cx="12188952" cy="50292"/>
+          </a:xfrm>
+          <a:prstGeom prst="rect">
+            <a:avLst/>
+          </a:prstGeom>
+          <a:solidFill>
+            <a:srgbClr val="1F2C56"/>
+          </a:solidFill>
+          <a:ln>
+            <a:noFill/>
+          </a:ln>
+        </p:spPr>
+        <p:style>
+          <a:lnRef idx="1">
+            <a:schemeClr val="accent1"/>
+          </a:lnRef>
+          <a:fillRef idx="3">
+            <a:schemeClr val="accent1"/>
+          </a:fillRef>
+          <a:effectRef idx="2">
+            <a:schemeClr val="accent1"/>
+          </a:effectRef>
+          <a:fontRef idx="minor">
+            <a:schemeClr val="lt1"/>
+          </a:fontRef>
+        </p:style>
+        <p:txBody>
+          <a:bodyPr rtlCol="0" anchor="ctr"/>
+          <a:lstStyle/>
+          <a:p>
+            <a:pPr algn="ctr"/>
+          </a:p>
+        </p:txBody>
+      </p:sp>
+      <p:sp>
+        <p:nvSpPr>
+          <p:cNvPr id="4" name="TextBox 3"/>
+          <p:cNvSpPr txBox="1"/>
+          <p:nvPr/>
+        </p:nvSpPr>
+        <p:spPr>
+          <a:xfrm>
+            <a:off x="685800" y="109728"/>
+            <a:ext cx="10817352" cy="228600"/>
+          </a:xfrm>
+          <a:prstGeom prst="rect">
+            <a:avLst/>
+          </a:prstGeom>
+          <a:noFill/>
+        </p:spPr>
+        <p:txBody>
+          <a:bodyPr wrap="none">
+            <a:spAutoFit/>
+          </a:bodyPr>
+          <a:lstStyle/>
+          <a:p>
+            <a:pPr algn="l"/>
+            <a:r>
+              <a:rPr sz="750">
+                <a:solidFill>
+                  <a:srgbClr val="78808C"/>
+                </a:solidFill>
+                <a:latin typeface="Consolas"/>
+              </a:rPr>
+              <a:t>VA11  ·  INHALT</a:t>
+            </a:r>
+          </a:p>
+        </p:txBody>
+      </p:sp>
+      <p:sp>
+        <p:nvSpPr>
+          <p:cNvPr id="5" name="Rectangle 4"/>
+          <p:cNvSpPr/>
+          <p:nvPr/>
+        </p:nvSpPr>
+        <p:spPr>
+          <a:xfrm>
+            <a:off x="0" y="1234440"/>
+            <a:ext cx="12188952" cy="12700"/>
+          </a:xfrm>
+          <a:prstGeom prst="rect">
+            <a:avLst/>
+          </a:prstGeom>
+          <a:solidFill>
+            <a:srgbClr val="D8DFE4"/>
+          </a:solidFill>
+          <a:ln>
+            <a:noFill/>
+          </a:ln>
+        </p:spPr>
+        <p:style>
+          <a:lnRef idx="1">
+            <a:schemeClr val="accent1"/>
+          </a:lnRef>
+          <a:fillRef idx="3">
+            <a:schemeClr val="accent1"/>
+          </a:fillRef>
+          <a:effectRef idx="2">
+            <a:schemeClr val="accent1"/>
+          </a:effectRef>
+          <a:fontRef idx="minor">
+            <a:schemeClr val="lt1"/>
+          </a:fontRef>
+        </p:style>
+        <p:txBody>
+          <a:bodyPr rtlCol="0" anchor="ctr"/>
+          <a:lstStyle/>
+          <a:p>
+            <a:pPr algn="ctr"/>
+          </a:p>
+        </p:txBody>
+      </p:sp>
+      <p:sp>
+        <p:nvSpPr>
+          <p:cNvPr id="6" name="Rectangle 5"/>
+          <p:cNvSpPr/>
+          <p:nvPr/>
+        </p:nvSpPr>
+        <p:spPr>
+          <a:xfrm>
+            <a:off x="685800" y="502920"/>
+            <a:ext cx="36576" cy="658368"/>
+          </a:xfrm>
+          <a:prstGeom prst="rect">
+            <a:avLst/>
+          </a:prstGeom>
+          <a:solidFill>
+            <a:srgbClr val="D9C089"/>
+          </a:solidFill>
+          <a:ln>
+            <a:noFill/>
+          </a:ln>
+        </p:spPr>
+        <p:style>
+          <a:lnRef idx="1">
+            <a:schemeClr val="accent1"/>
+          </a:lnRef>
+          <a:fillRef idx="3">
+            <a:schemeClr val="accent1"/>
+          </a:fillRef>
+          <a:effectRef idx="2">
+            <a:schemeClr val="accent1"/>
+          </a:effectRef>
+          <a:fontRef idx="minor">
+            <a:schemeClr val="lt1"/>
+          </a:fontRef>
+        </p:style>
+        <p:txBody>
+          <a:bodyPr rtlCol="0" anchor="ctr"/>
+          <a:lstStyle/>
+          <a:p>
+            <a:pPr algn="ctr"/>
+          </a:p>
+        </p:txBody>
+      </p:sp>
+      <p:sp>
+        <p:nvSpPr>
+          <p:cNvPr id="7" name="TextBox 6"/>
+          <p:cNvSpPr txBox="1"/>
+          <p:nvPr/>
+        </p:nvSpPr>
+        <p:spPr>
+          <a:xfrm>
+            <a:off x="813816" y="502920"/>
+            <a:ext cx="10634472" cy="685800"/>
+          </a:xfrm>
+          <a:prstGeom prst="rect">
+            <a:avLst/>
+          </a:prstGeom>
+          <a:noFill/>
+        </p:spPr>
+        <p:txBody>
+          <a:bodyPr wrap="square">
+            <a:spAutoFit/>
+          </a:bodyPr>
+          <a:lstStyle/>
+          <a:p>
+            <a:pPr algn="l"/>
+            <a:r>
+              <a:rPr sz="2400" b="1" i="0">
+                <a:solidFill>
+                  <a:srgbClr val="1F2C56"/>
+                </a:solidFill>
+                <a:latin typeface="Arial"/>
+              </a:rPr>
+              <a:t>Reflexionsfragen</a:t>
+            </a:r>
+          </a:p>
+        </p:txBody>
+      </p:sp>
+      <p:sp>
+        <p:nvSpPr>
+          <p:cNvPr id="8" name="TextBox 7"/>
+          <p:cNvSpPr txBox="1"/>
+          <p:nvPr/>
+        </p:nvSpPr>
+        <p:spPr>
+          <a:xfrm>
+            <a:off x="685800" y="1417320"/>
+            <a:ext cx="10817352" cy="4892040"/>
+          </a:xfrm>
+          <a:prstGeom prst="rect">
+            <a:avLst/>
+          </a:prstGeom>
+          <a:noFill/>
+        </p:spPr>
+        <p:txBody>
+          <a:bodyPr wrap="square" anchor="ctr">
+            <a:spAutoFit/>
+          </a:bodyPr>
+          <a:lstStyle/>
+          <a:p>
+            <a:pPr marL="190500" indent="-190500">
+              <a:spcBef>
+                <a:spcPts val="400"/>
+              </a:spcBef>
+              <a:spcAft>
+                <a:spcPts val="200"/>
+              </a:spcAft>
+            </a:pPr>
+            <a:r>
+              <a:rPr sz="1300">
+                <a:solidFill>
+                  <a:srgbClr val="3D5466"/>
+                </a:solidFill>
+                <a:latin typeface="Arial"/>
+              </a:rPr>
+              <a:t>▸  Welche Beteiligungsstruktur in Ihrem Bestand haben Sie noch nie vollständig durchgerechnet?</a:t>
+            </a:r>
+          </a:p>
+          <a:p>
+            <a:pPr marL="190500" indent="-190500">
+              <a:spcBef>
+                <a:spcPts val="400"/>
+              </a:spcBef>
+              <a:spcAft>
+                <a:spcPts val="200"/>
+              </a:spcAft>
+            </a:pPr>
+            <a:r>
+              <a:rPr sz="1300">
+                <a:solidFill>
+                  <a:srgbClr val="3D5466"/>
+                </a:solidFill>
+                <a:latin typeface="Arial"/>
+              </a:rPr>
+              <a:t>▸  Woran würden Sie im Alltag einen meldepflichtigen Verdachtsmoment erkennen?</a:t>
+            </a:r>
+          </a:p>
+          <a:p>
+            <a:pPr marL="190500" indent="-190500">
+              <a:spcBef>
+                <a:spcPts val="400"/>
+              </a:spcBef>
+              <a:spcAft>
+                <a:spcPts val="200"/>
+              </a:spcAft>
+            </a:pPr>
+            <a:r>
+              <a:rPr sz="1300">
+                <a:solidFill>
+                  <a:srgbClr val="3D5466"/>
+                </a:solidFill>
+                <a:latin typeface="Arial"/>
+              </a:rPr>
+              <a:t>▸  Wie reagieren Sie, wenn ein Berater Sie bittet, einen Vorgang trotz Ihrer Bedenken „einfach zu machen"?</a:t>
             </a:r>
           </a:p>
         </p:txBody>
@@ -6437,7 +8919,7 @@
             <a:avLst/>
           </a:prstGeom>
           <a:solidFill>
-            <a:srgbClr val="EDEDF3"/>
+            <a:srgbClr val="1F2C56"/>
           </a:solidFill>
           <a:ln>
             <a:noFill/>
@@ -6467,57 +8949,14 @@
       </p:sp>
       <p:sp>
         <p:nvSpPr>
-          <p:cNvPr id="3" name="Rectangle 2"/>
-          <p:cNvSpPr/>
-          <p:nvPr/>
-        </p:nvSpPr>
-        <p:spPr>
-          <a:xfrm>
-            <a:off x="0" y="0"/>
-            <a:ext cx="12188952" cy="50292"/>
-          </a:xfrm>
-          <a:prstGeom prst="rect">
-            <a:avLst/>
-          </a:prstGeom>
-          <a:solidFill>
-            <a:srgbClr val="1F2C56"/>
-          </a:solidFill>
-          <a:ln>
-            <a:noFill/>
-          </a:ln>
-        </p:spPr>
-        <p:style>
-          <a:lnRef idx="1">
-            <a:schemeClr val="accent1"/>
-          </a:lnRef>
-          <a:fillRef idx="3">
-            <a:schemeClr val="accent1"/>
-          </a:fillRef>
-          <a:effectRef idx="2">
-            <a:schemeClr val="accent1"/>
-          </a:effectRef>
-          <a:fontRef idx="minor">
-            <a:schemeClr val="lt1"/>
-          </a:fontRef>
-        </p:style>
-        <p:txBody>
-          <a:bodyPr rtlCol="0" anchor="ctr"/>
-          <a:lstStyle/>
-          <a:p>
-            <a:pPr algn="ctr"/>
-          </a:p>
-        </p:txBody>
-      </p:sp>
-      <p:sp>
-        <p:nvSpPr>
-          <p:cNvPr id="4" name="TextBox 3"/>
+          <p:cNvPr id="3" name="TextBox 2"/>
           <p:cNvSpPr txBox="1"/>
           <p:nvPr/>
         </p:nvSpPr>
         <p:spPr>
           <a:xfrm>
-            <a:off x="685800" y="109728"/>
-            <a:ext cx="10817352" cy="228600"/>
+            <a:off x="685800" y="2377440"/>
+            <a:ext cx="10817352" cy="365760"/>
           </a:xfrm>
           <a:prstGeom prst="rect">
             <a:avLst/>
@@ -6532,70 +8971,27 @@
           <a:p>
             <a:pPr algn="l"/>
             <a:r>
-              <a:rPr sz="750">
-                <a:solidFill>
-                  <a:srgbClr val="78808C"/>
+              <a:rPr sz="1200">
+                <a:solidFill>
+                  <a:srgbClr val="D9C089"/>
                 </a:solidFill>
                 <a:latin typeface="Consolas"/>
               </a:rPr>
-              <a:t>VA11  ·  INHALT</a:t>
-            </a:r>
-          </a:p>
-        </p:txBody>
-      </p:sp>
-      <p:sp>
-        <p:nvSpPr>
-          <p:cNvPr id="5" name="Rectangle 4"/>
+              <a:t>00:05–00:30</a:t>
+            </a:r>
+          </a:p>
+        </p:txBody>
+      </p:sp>
+      <p:sp>
+        <p:nvSpPr>
+          <p:cNvPr id="4" name="Rectangle 3"/>
           <p:cNvSpPr/>
           <p:nvPr/>
         </p:nvSpPr>
         <p:spPr>
           <a:xfrm>
-            <a:off x="0" y="1234440"/>
-            <a:ext cx="12188952" cy="12700"/>
-          </a:xfrm>
-          <a:prstGeom prst="rect">
-            <a:avLst/>
-          </a:prstGeom>
-          <a:solidFill>
-            <a:srgbClr val="D8DFE4"/>
-          </a:solidFill>
-          <a:ln>
-            <a:noFill/>
-          </a:ln>
-        </p:spPr>
-        <p:style>
-          <a:lnRef idx="1">
-            <a:schemeClr val="accent1"/>
-          </a:lnRef>
-          <a:fillRef idx="3">
-            <a:schemeClr val="accent1"/>
-          </a:fillRef>
-          <a:effectRef idx="2">
-            <a:schemeClr val="accent1"/>
-          </a:effectRef>
-          <a:fontRef idx="minor">
-            <a:schemeClr val="lt1"/>
-          </a:fontRef>
-        </p:style>
-        <p:txBody>
-          <a:bodyPr rtlCol="0" anchor="ctr"/>
-          <a:lstStyle/>
-          <a:p>
-            <a:pPr algn="ctr"/>
-          </a:p>
-        </p:txBody>
-      </p:sp>
-      <p:sp>
-        <p:nvSpPr>
-          <p:cNvPr id="6" name="Rectangle 5"/>
-          <p:cNvSpPr/>
-          <p:nvPr/>
-        </p:nvSpPr>
-        <p:spPr>
-          <a:xfrm>
-            <a:off x="685800" y="502920"/>
-            <a:ext cx="36576" cy="658368"/>
+            <a:off x="685800" y="2788920"/>
+            <a:ext cx="548640" cy="38100"/>
           </a:xfrm>
           <a:prstGeom prst="rect">
             <a:avLst/>
@@ -6631,14 +9027,14 @@
       </p:sp>
       <p:sp>
         <p:nvSpPr>
-          <p:cNvPr id="7" name="TextBox 6"/>
+          <p:cNvPr id="5" name="TextBox 4"/>
           <p:cNvSpPr txBox="1"/>
           <p:nvPr/>
         </p:nvSpPr>
         <p:spPr>
           <a:xfrm>
-            <a:off x="813816" y="502920"/>
-            <a:ext cx="10634472" cy="685800"/>
+            <a:off x="685800" y="3017520"/>
+            <a:ext cx="10817352" cy="1463040"/>
           </a:xfrm>
           <a:prstGeom prst="rect">
             <a:avLst/>
@@ -6653,27 +9049,27 @@
           <a:p>
             <a:pPr algn="l"/>
             <a:r>
-              <a:rPr sz="2400" b="1" i="0">
-                <a:solidFill>
-                  <a:srgbClr val="1F2C56"/>
+              <a:rPr sz="4000" b="1" i="0">
+                <a:solidFill>
+                  <a:srgbClr val="FFFFFF"/>
                 </a:solidFill>
                 <a:latin typeface="Arial"/>
               </a:rPr>
-              <a:t>Theorie-Input: Kreditnehmereinheit – Zweck und Bildungsregeln</a:t>
-            </a:r>
-          </a:p>
-        </p:txBody>
-      </p:sp>
-      <p:sp>
-        <p:nvSpPr>
-          <p:cNvPr id="8" name="TextBox 7"/>
+              <a:t>Theorie-Input 1 &amp; 2</a:t>
+            </a:r>
+          </a:p>
+        </p:txBody>
+      </p:sp>
+      <p:sp>
+        <p:nvSpPr>
+          <p:cNvPr id="6" name="TextBox 5"/>
           <p:cNvSpPr txBox="1"/>
           <p:nvPr/>
         </p:nvSpPr>
         <p:spPr>
           <a:xfrm>
-            <a:off x="685800" y="1417320"/>
-            <a:ext cx="10817352" cy="4892040"/>
+            <a:off x="685800" y="4480560"/>
+            <a:ext cx="8653881" cy="1280160"/>
           </a:xfrm>
           <a:prstGeom prst="rect">
             <a:avLst/>
@@ -6681,122 +9077,34 @@
           <a:noFill/>
         </p:spPr>
         <p:txBody>
-          <a:bodyPr wrap="square" anchor="ctr">
+          <a:bodyPr wrap="square">
             <a:spAutoFit/>
           </a:bodyPr>
           <a:lstStyle/>
           <a:p>
-            <a:pPr marL="190500" indent="-190500">
-              <a:spcBef>
-                <a:spcPts val="400"/>
-              </a:spcBef>
-              <a:spcAft>
-                <a:spcPts val="200"/>
-              </a:spcAft>
-            </a:pPr>
-            <a:r>
-              <a:rPr sz="1300">
-                <a:solidFill>
-                  <a:srgbClr val="3D5466"/>
+            <a:pPr algn="l"/>
+            <a:r>
+              <a:rPr sz="1600" b="0" i="0">
+                <a:solidFill>
+                  <a:srgbClr val="C8D2E6"/>
                 </a:solidFill>
                 <a:latin typeface="Arial"/>
               </a:rPr>
-              <a:t>▸  Wann bilden mehrere Kreditnehmer eine Einheit? § 19 Abs. 2 KWG kennt zwei Tatbestände:</a:t>
-            </a:r>
-          </a:p>
-          <a:p>
-            <a:pPr marL="190500" indent="-190500">
-              <a:spcBef>
-                <a:spcPts val="400"/>
-              </a:spcBef>
-              <a:spcAft>
-                <a:spcPts val="200"/>
-              </a:spcAft>
-            </a:pPr>
-            <a:r>
-              <a:rPr sz="1300">
-                <a:solidFill>
-                  <a:srgbClr val="3D5466"/>
-                </a:solidFill>
-                <a:latin typeface="Arial"/>
-              </a:rPr>
-              <a:t>▸  Wichtige Abgrenzung:</a:t>
-            </a:r>
-          </a:p>
-          <a:p>
-            <a:pPr marL="190500" indent="-190500">
-              <a:spcBef>
-                <a:spcPts val="400"/>
-              </a:spcBef>
-              <a:spcAft>
-                <a:spcPts val="200"/>
-              </a:spcAft>
-            </a:pPr>
-            <a:r>
-              <a:rPr sz="1300">
-                <a:solidFill>
-                  <a:srgbClr val="3D5466"/>
-                </a:solidFill>
-                <a:latin typeface="Arial"/>
-              </a:rPr>
-              <a:t>▸  Die Kreditnehmereinheit ist ein aufsichtsrechtliches Konzept – sie bestimmt, wie Kreditengagements gemessen und gemeldet werden. Sie sagt nichts darüber aus, wie die Betreuung organisiert ist.</a:t>
-            </a:r>
-          </a:p>
-        </p:txBody>
-      </p:sp>
-      <p:sp>
-        <p:nvSpPr>
-          <p:cNvPr id="9" name="Rectangle 8"/>
-          <p:cNvSpPr/>
-          <p:nvPr/>
-        </p:nvSpPr>
-        <p:spPr>
-          <a:xfrm>
-            <a:off x="0" y="6510528"/>
-            <a:ext cx="12188952" cy="347472"/>
-          </a:xfrm>
-          <a:prstGeom prst="rect">
-            <a:avLst/>
-          </a:prstGeom>
-          <a:solidFill>
-            <a:srgbClr val="0A1937"/>
-          </a:solidFill>
-          <a:ln>
-            <a:noFill/>
-          </a:ln>
-        </p:spPr>
-        <p:style>
-          <a:lnRef idx="1">
-            <a:schemeClr val="accent1"/>
-          </a:lnRef>
-          <a:fillRef idx="3">
-            <a:schemeClr val="accent1"/>
-          </a:fillRef>
-          <a:effectRef idx="2">
-            <a:schemeClr val="accent1"/>
-          </a:effectRef>
-          <a:fontRef idx="minor">
-            <a:schemeClr val="lt1"/>
-          </a:fontRef>
-        </p:style>
-        <p:txBody>
-          <a:bodyPr rtlCol="0" anchor="ctr"/>
-          <a:lstStyle/>
-          <a:p>
-            <a:pPr algn="ctr"/>
-          </a:p>
-        </p:txBody>
-      </p:sp>
-      <p:sp>
-        <p:nvSpPr>
-          <p:cNvPr id="10" name="TextBox 9"/>
+              <a:t>Kreditnehmereinheit bilden und den wirtschaftlich Berechtigten durchrechnen.</a:t>
+            </a:r>
+          </a:p>
+        </p:txBody>
+      </p:sp>
+      <p:sp>
+        <p:nvSpPr>
+          <p:cNvPr id="7" name="TextBox 6"/>
           <p:cNvSpPr txBox="1"/>
           <p:nvPr/>
         </p:nvSpPr>
         <p:spPr>
           <a:xfrm>
-            <a:off x="685800" y="6583680"/>
-            <a:ext cx="6490411" cy="256032"/>
+            <a:off x="685800" y="6355080"/>
+            <a:ext cx="10817352" cy="274320"/>
           </a:xfrm>
           <a:prstGeom prst="rect">
             <a:avLst/>
@@ -6813,7 +9121,7 @@
             <a:r>
               <a:rPr sz="700">
                 <a:solidFill>
-                  <a:srgbClr val="A0B4D2"/>
+                  <a:srgbClr val="8CA0C3"/>
                 </a:solidFill>
                 <a:latin typeface="Consolas"/>
               </a:rPr>
@@ -7077,7 +9385,7 @@
                 </a:solidFill>
                 <a:latin typeface="Arial"/>
               </a:rPr>
-              <a:t>Theorie-Input: Betreuungseinheit – vertriebliche Zusammenfassung</a:t>
+              <a:t>Einheit und wirtschaftlich Berechtigter</a:t>
             </a:r>
           </a:p>
         </p:txBody>
@@ -7099,7 +9407,7 @@
           <a:noFill/>
         </p:spPr>
         <p:txBody>
-          <a:bodyPr wrap="square" anchor="ctr">
+          <a:bodyPr wrap="square">
             <a:spAutoFit/>
           </a:bodyPr>
           <a:lstStyle/>
@@ -7119,26 +9427,102 @@
                 </a:solidFill>
                 <a:latin typeface="Arial"/>
               </a:rPr>
-              <a:t>→  Handlungsempfehlung</a:t>
-            </a:r>
-          </a:p>
-          <a:p>
-            <a:pPr marL="177800" indent="-177800">
+              <a:t>→  Mehrere Firmenkunden eines Inhabers sind oft mehr als Einzelengagements – aufsichtsrechtlich können sie eine Kreditnehmereinheit bilden.</a:t>
+            </a:r>
+          </a:p>
+          <a:p>
+            <a:pPr>
               <a:spcBef>
-                <a:spcPts val="600"/>
+                <a:spcPts val="1000"/>
               </a:spcBef>
               <a:spcAft>
                 <a:spcPts val="200"/>
               </a:spcAft>
             </a:pPr>
             <a:r>
-              <a:rPr sz="1200" i="1">
+              <a:rPr sz="800" b="1">
+                <a:solidFill>
+                  <a:srgbClr val="78808C"/>
+                </a:solidFill>
+                <a:latin typeface="Consolas"/>
+              </a:rPr>
+              <a:t>KREDITNEHMEREINHEIT (§ 19 ABS. 2 KWG)</a:t>
+            </a:r>
+          </a:p>
+          <a:p>
+            <a:pPr marL="190500" indent="-190500">
+              <a:spcBef>
+                <a:spcPts val="400"/>
+              </a:spcBef>
+              <a:spcAft>
+                <a:spcPts val="200"/>
+              </a:spcAft>
+            </a:pPr>
+            <a:r>
+              <a:rPr sz="1300">
                 <a:solidFill>
                   <a:srgbClr val="3D5466"/>
                 </a:solidFill>
                 <a:latin typeface="Arial"/>
               </a:rPr>
-              <a:t>→  Wenn mehrere Gesellschaften eines Inhabers im Bestand geführt werden</a:t>
+              <a:t>▸  Zwei Tatbestände: Beherrschung oder wirtschaftliche Abhängigkeit – greift einer, gehören die Gesellschaften in eine Einheit.</a:t>
+            </a:r>
+          </a:p>
+          <a:p>
+            <a:pPr marL="190500" indent="-190500">
+              <a:spcBef>
+                <a:spcPts val="400"/>
+              </a:spcBef>
+              <a:spcAft>
+                <a:spcPts val="200"/>
+              </a:spcAft>
+            </a:pPr>
+            <a:r>
+              <a:rPr sz="1300">
+                <a:solidFill>
+                  <a:srgbClr val="3D5466"/>
+                </a:solidFill>
+                <a:latin typeface="Arial"/>
+              </a:rPr>
+              <a:t>▸  Großkredit ab 10 % der anrechenbaren Eigenmittel (Art. 392 CRR); Meldepflichten aggregieren über die Einheit.</a:t>
+            </a:r>
+          </a:p>
+          <a:p>
+            <a:pPr>
+              <a:spcBef>
+                <a:spcPts val="1000"/>
+              </a:spcBef>
+              <a:spcAft>
+                <a:spcPts val="200"/>
+              </a:spcAft>
+            </a:pPr>
+            <a:r>
+              <a:rPr sz="800" b="1">
+                <a:solidFill>
+                  <a:srgbClr val="78808C"/>
+                </a:solidFill>
+                <a:latin typeface="Consolas"/>
+              </a:rPr>
+              <a:t>WIRTSCHAFTLICH BERECHTIGTER (§ 3 ABS. 2 GWG)</a:t>
+            </a:r>
+          </a:p>
+          <a:p>
+            <a:pPr marL="190500" indent="-190500">
+              <a:spcBef>
+                <a:spcPts val="400"/>
+              </a:spcBef>
+              <a:spcAft>
+                <a:spcPts val="200"/>
+              </a:spcAft>
+            </a:pPr>
+            <a:r>
+              <a:rPr sz="1300">
+                <a:solidFill>
+                  <a:srgbClr val="3D5466"/>
+                </a:solidFill>
+                <a:latin typeface="Arial"/>
+              </a:rPr>
+              <a:t>▸  Schwelle über 25 %; Ketten durchrechnen (z. B. 80 % × 70 % = 56 %). Transparenzregister abgleichen, Unstimmigkeit nach § 23a GwG melden.</a:t>
             </a:r>
           </a:p>
         </p:txBody>
@@ -7254,7 +9638,7 @@
             <a:avLst/>
           </a:prstGeom>
           <a:solidFill>
-            <a:srgbClr val="EDEDF3"/>
+            <a:srgbClr val="FFFFFF"/>
           </a:solidFill>
           <a:ln>
             <a:noFill/>
@@ -7355,51 +9739,43 @@
                 </a:solidFill>
                 <a:latin typeface="Consolas"/>
               </a:rPr>
-              <a:t>VA11  ·  INHALT</a:t>
-            </a:r>
-          </a:p>
-        </p:txBody>
-      </p:sp>
-      <p:sp>
-        <p:nvSpPr>
-          <p:cNvPr id="5" name="Rectangle 4"/>
-          <p:cNvSpPr/>
-          <p:nvPr/>
-        </p:nvSpPr>
-        <p:spPr>
-          <a:xfrm>
-            <a:off x="0" y="1234440"/>
-            <a:ext cx="12188952" cy="12700"/>
-          </a:xfrm>
-          <a:prstGeom prst="rect">
-            <a:avLst/>
-          </a:prstGeom>
-          <a:solidFill>
-            <a:srgbClr val="D8DFE4"/>
-          </a:solidFill>
-          <a:ln>
-            <a:noFill/>
-          </a:ln>
-        </p:spPr>
-        <p:style>
-          <a:lnRef idx="1">
-            <a:schemeClr val="accent1"/>
-          </a:lnRef>
-          <a:fillRef idx="3">
-            <a:schemeClr val="accent1"/>
-          </a:fillRef>
-          <a:effectRef idx="2">
-            <a:schemeClr val="accent1"/>
-          </a:effectRef>
-          <a:fontRef idx="minor">
-            <a:schemeClr val="lt1"/>
-          </a:fontRef>
-        </p:style>
-        <p:txBody>
-          <a:bodyPr rtlCol="0" anchor="ctr"/>
-          <a:lstStyle/>
-          <a:p>
-            <a:pPr algn="ctr"/>
+              <a:t>VA11  ·  SCHAUBILD</a:t>
+            </a:r>
+          </a:p>
+        </p:txBody>
+      </p:sp>
+      <p:sp>
+        <p:nvSpPr>
+          <p:cNvPr id="5" name="TextBox 4"/>
+          <p:cNvSpPr txBox="1"/>
+          <p:nvPr/>
+        </p:nvSpPr>
+        <p:spPr>
+          <a:xfrm>
+            <a:off x="685800" y="502920"/>
+            <a:ext cx="10817352" cy="594360"/>
+          </a:xfrm>
+          <a:prstGeom prst="rect">
+            <a:avLst/>
+          </a:prstGeom>
+          <a:noFill/>
+        </p:spPr>
+        <p:txBody>
+          <a:bodyPr wrap="square">
+            <a:spAutoFit/>
+          </a:bodyPr>
+          <a:lstStyle/>
+          <a:p>
+            <a:pPr algn="l"/>
+            <a:r>
+              <a:rPr sz="2000" b="1" i="0">
+                <a:solidFill>
+                  <a:srgbClr val="1F2C56"/>
+                </a:solidFill>
+                <a:latin typeface="Arial"/>
+              </a:rPr>
+              <a:t>Beteiligungsstruktur lesen: Einheit bilden, wB durchrechnen</a:t>
+            </a:r>
           </a:p>
         </p:txBody>
       </p:sp>
@@ -7411,8 +9787,8 @@
         </p:nvSpPr>
         <p:spPr>
           <a:xfrm>
-            <a:off x="685800" y="502920"/>
-            <a:ext cx="36576" cy="658368"/>
+            <a:off x="685800" y="1143000"/>
+            <a:ext cx="10817352" cy="25400"/>
           </a:xfrm>
           <a:prstGeom prst="rect">
             <a:avLst/>
@@ -7446,86 +9822,33 @@
           </a:p>
         </p:txBody>
       </p:sp>
-      <p:sp>
-        <p:nvSpPr>
-          <p:cNvPr id="7" name="TextBox 6"/>
-          <p:cNvSpPr txBox="1"/>
-          <p:nvPr/>
-        </p:nvSpPr>
-        <p:spPr>
-          <a:xfrm>
-            <a:off x="813816" y="502920"/>
-            <a:ext cx="10634472" cy="685800"/>
-          </a:xfrm>
-          <a:prstGeom prst="rect">
-            <a:avLst/>
-          </a:prstGeom>
-          <a:noFill/>
-        </p:spPr>
-        <p:txBody>
-          <a:bodyPr wrap="square">
-            <a:spAutoFit/>
-          </a:bodyPr>
-          <a:lstStyle/>
-          <a:p>
-            <a:pPr algn="l"/>
-            <a:r>
-              <a:rPr sz="2400" b="1" i="0">
-                <a:solidFill>
-                  <a:srgbClr val="1F2C56"/>
-                </a:solidFill>
-                <a:latin typeface="Arial"/>
-              </a:rPr>
-              <a:t>Theorie-Input: Wirtschaftlich Berechtigter – Ermittlung nach GwG</a:t>
-            </a:r>
-          </a:p>
-        </p:txBody>
-      </p:sp>
-      <p:sp>
-        <p:nvSpPr>
-          <p:cNvPr id="8" name="TextBox 7"/>
-          <p:cNvSpPr txBox="1"/>
-          <p:nvPr/>
-        </p:nvSpPr>
-        <p:spPr>
-          <a:xfrm>
-            <a:off x="685800" y="1417320"/>
-            <a:ext cx="10817352" cy="4892040"/>
-          </a:xfrm>
-          <a:prstGeom prst="rect">
-            <a:avLst/>
-          </a:prstGeom>
-          <a:noFill/>
-        </p:spPr>
-        <p:txBody>
-          <a:bodyPr wrap="square" anchor="ctr">
-            <a:spAutoFit/>
-          </a:bodyPr>
-          <a:lstStyle/>
-          <a:p>
-            <a:pPr marL="190500" indent="-190500">
-              <a:spcBef>
-                <a:spcPts val="400"/>
-              </a:spcBef>
-              <a:spcAft>
-                <a:spcPts val="200"/>
-              </a:spcAft>
-            </a:pPr>
-            <a:r>
-              <a:rPr sz="1300">
-                <a:solidFill>
-                  <a:srgbClr val="3D5466"/>
-                </a:solidFill>
-                <a:latin typeface="Arial"/>
-              </a:rPr>
-              <a:t>▸  Zusammenfassung Ermittlungsschritte:</a:t>
-            </a:r>
-          </a:p>
-        </p:txBody>
-      </p:sp>
-      <p:sp>
-        <p:nvSpPr>
-          <p:cNvPr id="9" name="Rectangle 8"/>
+      <p:pic>
+        <p:nvPicPr>
+          <p:cNvPr id="7" name="Picture 6" descr="image.png"/>
+          <p:cNvPicPr>
+            <a:picLocks noChangeAspect="1"/>
+          </p:cNvPicPr>
+          <p:nvPr/>
+        </p:nvPicPr>
+        <p:blipFill>
+          <a:blip r:embed="rId2"/>
+          <a:stretch>
+            <a:fillRect/>
+          </a:stretch>
+        </p:blipFill>
+        <p:spPr>
+          <a:xfrm>
+            <a:off x="2303489" y="1325880"/>
+            <a:ext cx="7581973" cy="4937760"/>
+          </a:xfrm>
+          <a:prstGeom prst="rect">
+            <a:avLst/>
+          </a:prstGeom>
+        </p:spPr>
+      </p:pic>
+      <p:sp>
+        <p:nvSpPr>
+          <p:cNvPr id="8" name="Rectangle 7"/>
           <p:cNvSpPr/>
           <p:nvPr/>
         </p:nvSpPr>
@@ -7568,7 +9891,7 @@
       </p:sp>
       <p:sp>
         <p:nvSpPr>
-          <p:cNvPr id="10" name="TextBox 9"/>
+          <p:cNvPr id="9" name="TextBox 8"/>
           <p:cNvSpPr txBox="1"/>
           <p:nvPr/>
         </p:nvSpPr>
@@ -7597,6 +9920,41 @@
                 <a:latin typeface="Consolas"/>
               </a:rPr>
               <a:t>FKB Campus  ·  VA11</a:t>
+            </a:r>
+          </a:p>
+        </p:txBody>
+      </p:sp>
+      <p:sp>
+        <p:nvSpPr>
+          <p:cNvPr id="10" name="TextBox 9"/>
+          <p:cNvSpPr txBox="1"/>
+          <p:nvPr/>
+        </p:nvSpPr>
+        <p:spPr>
+          <a:xfrm>
+            <a:off x="7176211" y="6583680"/>
+            <a:ext cx="4326940" cy="256032"/>
+          </a:xfrm>
+          <a:prstGeom prst="rect">
+            <a:avLst/>
+          </a:prstGeom>
+          <a:noFill/>
+        </p:spPr>
+        <p:txBody>
+          <a:bodyPr wrap="none">
+            <a:spAutoFit/>
+          </a:bodyPr>
+          <a:lstStyle/>
+          <a:p>
+            <a:pPr algn="r"/>
+            <a:r>
+              <a:rPr sz="700">
+                <a:solidFill>
+                  <a:srgbClr val="A0B4D2"/>
+                </a:solidFill>
+                <a:latin typeface="Consolas"/>
+              </a:rPr>
+              <a:t>Schaubild</a:t>
             </a:r>
           </a:p>
         </p:txBody>
@@ -7634,7 +9992,7 @@
             <a:avLst/>
           </a:prstGeom>
           <a:solidFill>
-            <a:srgbClr val="EDEDF3"/>
+            <a:srgbClr val="1F2C56"/>
           </a:solidFill>
           <a:ln>
             <a:noFill/>
@@ -7664,57 +10022,14 @@
       </p:sp>
       <p:sp>
         <p:nvSpPr>
-          <p:cNvPr id="3" name="Rectangle 2"/>
-          <p:cNvSpPr/>
-          <p:nvPr/>
-        </p:nvSpPr>
-        <p:spPr>
-          <a:xfrm>
-            <a:off x="0" y="0"/>
-            <a:ext cx="12188952" cy="50292"/>
-          </a:xfrm>
-          <a:prstGeom prst="rect">
-            <a:avLst/>
-          </a:prstGeom>
-          <a:solidFill>
-            <a:srgbClr val="1F2C56"/>
-          </a:solidFill>
-          <a:ln>
-            <a:noFill/>
-          </a:ln>
-        </p:spPr>
-        <p:style>
-          <a:lnRef idx="1">
-            <a:schemeClr val="accent1"/>
-          </a:lnRef>
-          <a:fillRef idx="3">
-            <a:schemeClr val="accent1"/>
-          </a:fillRef>
-          <a:effectRef idx="2">
-            <a:schemeClr val="accent1"/>
-          </a:effectRef>
-          <a:fontRef idx="minor">
-            <a:schemeClr val="lt1"/>
-          </a:fontRef>
-        </p:style>
-        <p:txBody>
-          <a:bodyPr rtlCol="0" anchor="ctr"/>
-          <a:lstStyle/>
-          <a:p>
-            <a:pPr algn="ctr"/>
-          </a:p>
-        </p:txBody>
-      </p:sp>
-      <p:sp>
-        <p:nvSpPr>
-          <p:cNvPr id="4" name="TextBox 3"/>
+          <p:cNvPr id="3" name="TextBox 2"/>
           <p:cNvSpPr txBox="1"/>
           <p:nvPr/>
         </p:nvSpPr>
         <p:spPr>
           <a:xfrm>
-            <a:off x="685800" y="109728"/>
-            <a:ext cx="10817352" cy="228600"/>
+            <a:off x="685800" y="2377440"/>
+            <a:ext cx="10817352" cy="365760"/>
           </a:xfrm>
           <a:prstGeom prst="rect">
             <a:avLst/>
@@ -7729,70 +10044,27 @@
           <a:p>
             <a:pPr algn="l"/>
             <a:r>
-              <a:rPr sz="750">
-                <a:solidFill>
-                  <a:srgbClr val="78808C"/>
+              <a:rPr sz="1200">
+                <a:solidFill>
+                  <a:srgbClr val="D9C089"/>
                 </a:solidFill>
                 <a:latin typeface="Consolas"/>
               </a:rPr>
-              <a:t>VA11  ·  INHALT</a:t>
-            </a:r>
-          </a:p>
-        </p:txBody>
-      </p:sp>
-      <p:sp>
-        <p:nvSpPr>
-          <p:cNvPr id="5" name="Rectangle 4"/>
+              <a:t>00:30–00:40</a:t>
+            </a:r>
+          </a:p>
+        </p:txBody>
+      </p:sp>
+      <p:sp>
+        <p:nvSpPr>
+          <p:cNvPr id="4" name="Rectangle 3"/>
           <p:cNvSpPr/>
           <p:nvPr/>
         </p:nvSpPr>
         <p:spPr>
           <a:xfrm>
-            <a:off x="0" y="1234440"/>
-            <a:ext cx="12188952" cy="12700"/>
-          </a:xfrm>
-          <a:prstGeom prst="rect">
-            <a:avLst/>
-          </a:prstGeom>
-          <a:solidFill>
-            <a:srgbClr val="D8DFE4"/>
-          </a:solidFill>
-          <a:ln>
-            <a:noFill/>
-          </a:ln>
-        </p:spPr>
-        <p:style>
-          <a:lnRef idx="1">
-            <a:schemeClr val="accent1"/>
-          </a:lnRef>
-          <a:fillRef idx="3">
-            <a:schemeClr val="accent1"/>
-          </a:fillRef>
-          <a:effectRef idx="2">
-            <a:schemeClr val="accent1"/>
-          </a:effectRef>
-          <a:fontRef idx="minor">
-            <a:schemeClr val="lt1"/>
-          </a:fontRef>
-        </p:style>
-        <p:txBody>
-          <a:bodyPr rtlCol="0" anchor="ctr"/>
-          <a:lstStyle/>
-          <a:p>
-            <a:pPr algn="ctr"/>
-          </a:p>
-        </p:txBody>
-      </p:sp>
-      <p:sp>
-        <p:nvSpPr>
-          <p:cNvPr id="6" name="Rectangle 5"/>
-          <p:cNvSpPr/>
-          <p:nvPr/>
-        </p:nvSpPr>
-        <p:spPr>
-          <a:xfrm>
-            <a:off x="685800" y="502920"/>
-            <a:ext cx="36576" cy="658368"/>
+            <a:off x="685800" y="2788920"/>
+            <a:ext cx="548640" cy="38100"/>
           </a:xfrm>
           <a:prstGeom prst="rect">
             <a:avLst/>
@@ -7828,14 +10100,14 @@
       </p:sp>
       <p:sp>
         <p:nvSpPr>
-          <p:cNvPr id="7" name="TextBox 6"/>
+          <p:cNvPr id="5" name="TextBox 4"/>
           <p:cNvSpPr txBox="1"/>
           <p:nvPr/>
         </p:nvSpPr>
         <p:spPr>
           <a:xfrm>
-            <a:off x="813816" y="502920"/>
-            <a:ext cx="10634472" cy="685800"/>
+            <a:off x="685800" y="3017520"/>
+            <a:ext cx="10817352" cy="1463040"/>
           </a:xfrm>
           <a:prstGeom prst="rect">
             <a:avLst/>
@@ -7850,27 +10122,27 @@
           <a:p>
             <a:pPr algn="l"/>
             <a:r>
-              <a:rPr sz="2400" b="1" i="0">
-                <a:solidFill>
-                  <a:srgbClr val="1F2C56"/>
+              <a:rPr sz="4000" b="1" i="0">
+                <a:solidFill>
+                  <a:srgbClr val="FFFFFF"/>
                 </a:solidFill>
                 <a:latin typeface="Arial"/>
               </a:rPr>
-              <a:t>Theorie-Input: Geldwäscheprävention im Innendienst</a:t>
-            </a:r>
-          </a:p>
-        </p:txBody>
-      </p:sp>
-      <p:sp>
-        <p:nvSpPr>
-          <p:cNvPr id="8" name="TextBox 7"/>
+              <a:t>Theorie-Input 3</a:t>
+            </a:r>
+          </a:p>
+        </p:txBody>
+      </p:sp>
+      <p:sp>
+        <p:nvSpPr>
+          <p:cNvPr id="6" name="TextBox 5"/>
           <p:cNvSpPr txBox="1"/>
           <p:nvPr/>
         </p:nvSpPr>
         <p:spPr>
           <a:xfrm>
-            <a:off x="685800" y="1417320"/>
-            <a:ext cx="10817352" cy="4892040"/>
+            <a:off x="685800" y="4480560"/>
+            <a:ext cx="8653881" cy="1280160"/>
           </a:xfrm>
           <a:prstGeom prst="rect">
             <a:avLst/>
@@ -7883,212 +10155,29 @@
           </a:bodyPr>
           <a:lstStyle/>
           <a:p>
-            <a:pPr marL="190500" indent="-190500">
-              <a:spcBef>
-                <a:spcPts val="400"/>
-              </a:spcBef>
-              <a:spcAft>
-                <a:spcPts val="200"/>
-              </a:spcAft>
-            </a:pPr>
-            <a:r>
-              <a:rPr sz="1300">
-                <a:solidFill>
-                  <a:srgbClr val="3D5466"/>
+            <a:pPr algn="l"/>
+            <a:r>
+              <a:rPr sz="1600" b="0" i="0">
+                <a:solidFill>
+                  <a:srgbClr val="C8D2E6"/>
                 </a:solidFill>
                 <a:latin typeface="Arial"/>
               </a:rPr>
-              <a:t>▸  Typische Verdachtsmomente im Firmenkundeninnendienst:</a:t>
-            </a:r>
-          </a:p>
-          <a:p>
-            <a:pPr marL="177800" indent="-177800">
-              <a:spcBef>
-                <a:spcPts val="600"/>
-              </a:spcBef>
-              <a:spcAft>
-                <a:spcPts val="200"/>
-              </a:spcAft>
-            </a:pPr>
-            <a:r>
-              <a:rPr sz="1200" i="1">
-                <a:solidFill>
-                  <a:srgbClr val="3D5466"/>
-                </a:solidFill>
-                <a:latin typeface="Arial"/>
-              </a:rPr>
-              <a:t>→  Handlungsempfehlung</a:t>
-            </a:r>
-          </a:p>
-          <a:p>
-            <a:pPr marL="177800" indent="-177800">
-              <a:spcBef>
-                <a:spcPts val="600"/>
-              </a:spcBef>
-              <a:spcAft>
-                <a:spcPts val="200"/>
-              </a:spcAft>
-            </a:pPr>
-            <a:r>
-              <a:rPr sz="1200" i="1">
-                <a:solidFill>
-                  <a:srgbClr val="3D5466"/>
-                </a:solidFill>
-                <a:latin typeface="Arial"/>
-              </a:rPr>
-              <a:t>→  Wenn ein Verdachtsmoment wahrgenommen wird (unübliche Transaktion, inkonsistente Angaben, strukturierter Barverkehr)</a:t>
-            </a:r>
-          </a:p>
-          <a:p>
-            <a:pPr marL="177800" indent="-177800">
-              <a:spcBef>
-                <a:spcPts val="600"/>
-              </a:spcBef>
-              <a:spcAft>
-                <a:spcPts val="200"/>
-              </a:spcAft>
-            </a:pPr>
-            <a:r>
-              <a:rPr sz="1200" i="1">
-                <a:solidFill>
-                  <a:srgbClr val="3D5466"/>
-                </a:solidFill>
-                <a:latin typeface="Arial"/>
-              </a:rPr>
-              <a:t>→  Dann den Vorgang schriftlich dokumentieren, nichts am Ablauf ändern und unverzüglich den Geldwäschebeauftragten informieren – NICHT den Kunden ansprechen (Tipping-off-Verbot)</a:t>
-            </a:r>
-          </a:p>
-          <a:p>
-            <a:pPr marL="177800" indent="-177800">
-              <a:spcBef>
-                <a:spcPts val="600"/>
-              </a:spcBef>
-              <a:spcAft>
-                <a:spcPts val="200"/>
-              </a:spcAft>
-            </a:pPr>
-            <a:r>
-              <a:rPr sz="1200" i="1">
-                <a:solidFill>
-                  <a:srgbClr val="3D5466"/>
-                </a:solidFill>
-                <a:latin typeface="Arial"/>
-              </a:rPr>
-              <a:t>→  Handlungsempfehlung</a:t>
-            </a:r>
-          </a:p>
-          <a:p>
-            <a:pPr marL="177800" indent="-177800">
-              <a:spcBef>
-                <a:spcPts val="600"/>
-              </a:spcBef>
-              <a:spcAft>
-                <a:spcPts val="200"/>
-              </a:spcAft>
-            </a:pPr>
-            <a:r>
-              <a:rPr sz="1200" i="1">
-                <a:solidFill>
-                  <a:srgbClr val="3D5466"/>
-                </a:solidFill>
-                <a:latin typeface="Arial"/>
-              </a:rPr>
-              <a:t>→  Wenn der Berater Druck macht, eine Stammdatenänderung oder Transaktion trotz eines erkannten Verdachts „einfach durchzuführen"</a:t>
-            </a:r>
-          </a:p>
-          <a:p>
-            <a:pPr marL="177800" indent="-177800">
-              <a:spcBef>
-                <a:spcPts val="600"/>
-              </a:spcBef>
-              <a:spcAft>
-                <a:spcPts val="200"/>
-              </a:spcAft>
-            </a:pPr>
-            <a:r>
-              <a:rPr sz="1200" i="1">
-                <a:solidFill>
-                  <a:srgbClr val="3D5466"/>
-                </a:solidFill>
-                <a:latin typeface="Arial"/>
-              </a:rPr>
-              <a:t>→  Handlungsempfehlung</a:t>
-            </a:r>
-          </a:p>
-          <a:p>
-            <a:pPr marL="177800" indent="-177800">
-              <a:spcBef>
-                <a:spcPts val="600"/>
-              </a:spcBef>
-              <a:spcAft>
-                <a:spcPts val="200"/>
-              </a:spcAft>
-            </a:pPr>
-            <a:r>
-              <a:rPr sz="1200" i="1">
-                <a:solidFill>
-                  <a:srgbClr val="3D5466"/>
-                </a:solidFill>
-                <a:latin typeface="Arial"/>
-              </a:rPr>
-              <a:t>→  Wenn der wirtschaftlich Berechtigte nicht eindeutig ermittelt werden kann</a:t>
-            </a:r>
-          </a:p>
-        </p:txBody>
-      </p:sp>
-      <p:sp>
-        <p:nvSpPr>
-          <p:cNvPr id="9" name="Rectangle 8"/>
-          <p:cNvSpPr/>
-          <p:nvPr/>
-        </p:nvSpPr>
-        <p:spPr>
-          <a:xfrm>
-            <a:off x="0" y="6510528"/>
-            <a:ext cx="12188952" cy="347472"/>
-          </a:xfrm>
-          <a:prstGeom prst="rect">
-            <a:avLst/>
-          </a:prstGeom>
-          <a:solidFill>
-            <a:srgbClr val="0A1937"/>
-          </a:solidFill>
-          <a:ln>
-            <a:noFill/>
-          </a:ln>
-        </p:spPr>
-        <p:style>
-          <a:lnRef idx="1">
-            <a:schemeClr val="accent1"/>
-          </a:lnRef>
-          <a:fillRef idx="3">
-            <a:schemeClr val="accent1"/>
-          </a:fillRef>
-          <a:effectRef idx="2">
-            <a:schemeClr val="accent1"/>
-          </a:effectRef>
-          <a:fontRef idx="minor">
-            <a:schemeClr val="lt1"/>
-          </a:fontRef>
-        </p:style>
-        <p:txBody>
-          <a:bodyPr rtlCol="0" anchor="ctr"/>
-          <a:lstStyle/>
-          <a:p>
-            <a:pPr algn="ctr"/>
-          </a:p>
-        </p:txBody>
-      </p:sp>
-      <p:sp>
-        <p:nvSpPr>
-          <p:cNvPr id="10" name="TextBox 9"/>
+              <a:t>Verdachtsmomente erkennen und den Eskalationsweg sicher einhalten.</a:t>
+            </a:r>
+          </a:p>
+        </p:txBody>
+      </p:sp>
+      <p:sp>
+        <p:nvSpPr>
+          <p:cNvPr id="7" name="TextBox 6"/>
           <p:cNvSpPr txBox="1"/>
           <p:nvPr/>
         </p:nvSpPr>
         <p:spPr>
           <a:xfrm>
-            <a:off x="685800" y="6583680"/>
-            <a:ext cx="6490411" cy="256032"/>
+            <a:off x="685800" y="6355080"/>
+            <a:ext cx="10817352" cy="274320"/>
           </a:xfrm>
           <a:prstGeom prst="rect">
             <a:avLst/>
@@ -8105,7 +10194,7 @@
             <a:r>
               <a:rPr sz="700">
                 <a:solidFill>
-                  <a:srgbClr val="A0B4D2"/>
+                  <a:srgbClr val="8CA0C3"/>
                 </a:solidFill>
                 <a:latin typeface="Consolas"/>
               </a:rPr>
@@ -8248,7 +10337,7 @@
                 </a:solidFill>
                 <a:latin typeface="Consolas"/>
               </a:rPr>
-              <a:t>VA11  ·  ARBEITSBLATT</a:t>
+              <a:t>VA11  ·  INHALT</a:t>
             </a:r>
           </a:p>
         </p:txBody>
@@ -8369,7 +10458,7 @@
                 </a:solidFill>
                 <a:latin typeface="Arial"/>
               </a:rPr>
-              <a:t>Praxisfall: Beteiligungsstruktur Muster Holding</a:t>
+              <a:t>Geldwäscheprävention: erkennen und melden</a:t>
             </a:r>
           </a:p>
         </p:txBody>
@@ -8382,8 +10471,8 @@
         </p:nvSpPr>
         <p:spPr>
           <a:xfrm>
-            <a:off x="685800" y="1554480"/>
-            <a:ext cx="10817352" cy="3840480"/>
+            <a:off x="685800" y="1417320"/>
+            <a:ext cx="10817352" cy="4892040"/>
           </a:xfrm>
           <a:prstGeom prst="rect">
             <a:avLst/>
@@ -8391,10 +10480,29 @@
           <a:noFill/>
         </p:spPr>
         <p:txBody>
-          <a:bodyPr wrap="square">
+          <a:bodyPr wrap="square" anchor="ctr">
             <a:spAutoFit/>
           </a:bodyPr>
           <a:lstStyle/>
+          <a:p>
+            <a:pPr marL="177800" indent="-177800">
+              <a:spcBef>
+                <a:spcPts val="600"/>
+              </a:spcBef>
+              <a:spcAft>
+                <a:spcPts val="200"/>
+              </a:spcAft>
+            </a:pPr>
+            <a:r>
+              <a:rPr sz="1200" i="1">
+                <a:solidFill>
+                  <a:srgbClr val="3D5466"/>
+                </a:solidFill>
+                <a:latin typeface="Arial"/>
+              </a:rPr>
+              <a:t>→  Die Assistenz erkennt und meldet – sie entscheidet nicht. Wer dokumentiert und eskaliert, ist abgesichert.</a:t>
+            </a:r>
+          </a:p>
           <a:p>
             <a:pPr marL="190500" indent="-190500">
               <a:spcBef>
@@ -8405,13 +10513,13 @@
               </a:spcAft>
             </a:pPr>
             <a:r>
-              <a:rPr sz="1400">
+              <a:rPr sz="1300">
                 <a:solidFill>
                   <a:srgbClr val="3D5466"/>
                 </a:solidFill>
                 <a:latin typeface="Arial"/>
               </a:rPr>
-              <a:t>▸  Ausgangslage (anonymisiert)</a:t>
+              <a:t>▸  Der Innendienst ist der erste Kontaktpunkt, an dem Unstimmigkeiten und ungewöhnliche Muster sichtbar werden.</a:t>
             </a:r>
           </a:p>
           <a:p>
@@ -8424,13 +10532,13 @@
               </a:spcAft>
             </a:pPr>
             <a:r>
-              <a:rPr sz="1400">
+              <a:rPr sz="1300">
                 <a:solidFill>
                   <a:srgbClr val="3D5466"/>
                 </a:solidFill>
                 <a:latin typeface="Arial"/>
               </a:rPr>
-              <a:t>▸  Beteiligungsstruktur:</a:t>
+              <a:t>▸  Bei Verdacht: schriftlich dokumentieren, nichts am Ablauf ändern, unverzüglich den Geldwäschebeauftragten informieren.</a:t>
             </a:r>
           </a:p>
           <a:p>
@@ -8443,51 +10551,13 @@
               </a:spcAft>
             </a:pPr>
             <a:r>
-              <a:rPr sz="1400">
+              <a:rPr sz="1300">
                 <a:solidFill>
                   <a:srgbClr val="3D5466"/>
                 </a:solidFill>
                 <a:latin typeface="Arial"/>
               </a:rPr>
-              <a:t>▸  ```</a:t>
-            </a:r>
-          </a:p>
-          <a:p>
-            <a:pPr marL="190500" indent="-190500">
-              <a:spcBef>
-                <a:spcPts val="400"/>
-              </a:spcBef>
-              <a:spcAft>
-                <a:spcPts val="200"/>
-              </a:spcAft>
-            </a:pPr>
-            <a:r>
-              <a:rPr sz="1400">
-                <a:solidFill>
-                  <a:srgbClr val="3D5466"/>
-                </a:solidFill>
-                <a:latin typeface="Arial"/>
-              </a:rPr>
-              <a:t>▸  Georg Muster (natürliche Person)</a:t>
-            </a:r>
-          </a:p>
-          <a:p>
-            <a:pPr marL="190500" indent="-190500">
-              <a:spcBef>
-                <a:spcPts val="400"/>
-              </a:spcBef>
-              <a:spcAft>
-                <a:spcPts val="200"/>
-              </a:spcAft>
-            </a:pPr>
-            <a:r>
-              <a:rPr sz="1400">
-                <a:solidFill>
-                  <a:srgbClr val="3D5466"/>
-                </a:solidFill>
-                <a:latin typeface="Arial"/>
-              </a:rPr>
-              <a:t>▸  Sandra Muster (Ehefrau Georg Muster)</a:t>
+              <a:t>▸  Tipping-off-Verbot (§ 47 GwG): den Kunden nicht auf den Verdacht ansprechen. Die Sorgfaltspflicht ist nicht ermessensabhängig.</a:t>
             </a:r>
           </a:p>
         </p:txBody>
@@ -8495,84 +10565,6 @@
       <p:sp>
         <p:nvSpPr>
           <p:cNvPr id="9" name="Rectangle 8"/>
-          <p:cNvSpPr/>
-          <p:nvPr/>
-        </p:nvSpPr>
-        <p:spPr>
-          <a:xfrm>
-            <a:off x="685800" y="5486400"/>
-            <a:ext cx="10817352" cy="640080"/>
-          </a:xfrm>
-          <a:prstGeom prst="rect">
-            <a:avLst/>
-          </a:prstGeom>
-          <a:solidFill>
-            <a:srgbClr val="1F2C56"/>
-          </a:solidFill>
-          <a:ln>
-            <a:noFill/>
-          </a:ln>
-        </p:spPr>
-        <p:style>
-          <a:lnRef idx="1">
-            <a:schemeClr val="accent1"/>
-          </a:lnRef>
-          <a:fillRef idx="3">
-            <a:schemeClr val="accent1"/>
-          </a:fillRef>
-          <a:effectRef idx="2">
-            <a:schemeClr val="accent1"/>
-          </a:effectRef>
-          <a:fontRef idx="minor">
-            <a:schemeClr val="lt1"/>
-          </a:fontRef>
-        </p:style>
-        <p:txBody>
-          <a:bodyPr rtlCol="0" anchor="ctr"/>
-          <a:lstStyle/>
-          <a:p>
-            <a:pPr algn="ctr"/>
-          </a:p>
-        </p:txBody>
-      </p:sp>
-      <p:sp>
-        <p:nvSpPr>
-          <p:cNvPr id="10" name="TextBox 9"/>
-          <p:cNvSpPr txBox="1"/>
-          <p:nvPr/>
-        </p:nvSpPr>
-        <p:spPr>
-          <a:xfrm>
-            <a:off x="868680" y="5596128"/>
-            <a:ext cx="10451592" cy="457200"/>
-          </a:xfrm>
-          <a:prstGeom prst="rect">
-            <a:avLst/>
-          </a:prstGeom>
-          <a:noFill/>
-        </p:spPr>
-        <p:txBody>
-          <a:bodyPr wrap="square">
-            <a:spAutoFit/>
-          </a:bodyPr>
-          <a:lstStyle/>
-          <a:p>
-            <a:pPr algn="l"/>
-            <a:r>
-              <a:rPr sz="1300" b="1" i="0">
-                <a:solidFill>
-                  <a:srgbClr val="FFFFFF"/>
-                </a:solidFill>
-                <a:latin typeface="Arial"/>
-              </a:rPr>
-              <a:t>→  Bearbeitung im Teilnehmer-Workbook (Arbeitsblatt mit Ausfüllfeldern)</a:t>
-            </a:r>
-          </a:p>
-        </p:txBody>
-      </p:sp>
-      <p:sp>
-        <p:nvSpPr>
-          <p:cNvPr id="11" name="Rectangle 10"/>
           <p:cNvSpPr/>
           <p:nvPr/>
         </p:nvSpPr>
@@ -8615,7 +10607,7 @@
       </p:sp>
       <p:sp>
         <p:nvSpPr>
-          <p:cNvPr id="12" name="TextBox 11"/>
+          <p:cNvPr id="10" name="TextBox 9"/>
           <p:cNvSpPr txBox="1"/>
           <p:nvPr/>
         </p:nvSpPr>

</xml_diff>